<commit_message>
added Design pattern PPT
</commit_message>
<xml_diff>
--- a/Software Design Patterns PPT.pptx
+++ b/Software Design Patterns PPT.pptx
@@ -16,12 +16,28 @@
     <p:sldId id="263" r:id="rId10"/>
     <p:sldId id="265" r:id="rId11"/>
     <p:sldId id="266" r:id="rId12"/>
-    <p:sldId id="272" r:id="rId13"/>
-    <p:sldId id="271" r:id="rId14"/>
-    <p:sldId id="270" r:id="rId15"/>
-    <p:sldId id="269" r:id="rId16"/>
-    <p:sldId id="267" r:id="rId17"/>
-    <p:sldId id="268" r:id="rId18"/>
+    <p:sldId id="273" r:id="rId13"/>
+    <p:sldId id="274" r:id="rId14"/>
+    <p:sldId id="275" r:id="rId15"/>
+    <p:sldId id="276" r:id="rId16"/>
+    <p:sldId id="277" r:id="rId17"/>
+    <p:sldId id="278" r:id="rId18"/>
+    <p:sldId id="279" r:id="rId19"/>
+    <p:sldId id="280" r:id="rId20"/>
+    <p:sldId id="281" r:id="rId21"/>
+    <p:sldId id="282" r:id="rId22"/>
+    <p:sldId id="272" r:id="rId23"/>
+    <p:sldId id="283" r:id="rId24"/>
+    <p:sldId id="284" r:id="rId25"/>
+    <p:sldId id="285" r:id="rId26"/>
+    <p:sldId id="286" r:id="rId27"/>
+    <p:sldId id="287" r:id="rId28"/>
+    <p:sldId id="271" r:id="rId29"/>
+    <p:sldId id="288" r:id="rId30"/>
+    <p:sldId id="270" r:id="rId31"/>
+    <p:sldId id="269" r:id="rId32"/>
+    <p:sldId id="267" r:id="rId33"/>
+    <p:sldId id="268" r:id="rId34"/>
   </p:sldIdLst>
   <p:sldSz cx="12192000" cy="6858000"/>
   <p:notesSz cx="6858000" cy="9144000"/>
@@ -120,6 +136,11 @@
       </a:defRPr>
     </a:lvl9pPr>
   </p:defaultTextStyle>
+  <p:extLst>
+    <p:ext uri="{EFAFB233-063F-42B5-8137-9DF3F51BA10A}">
+      <p15:sldGuideLst xmlns:p15="http://schemas.microsoft.com/office/powerpoint/2012/main"/>
+    </p:ext>
+  </p:extLst>
 </p:presentation>
 </file>
 
@@ -165,7 +186,7 @@
           </a:lstStyle>
           <a:p>
             <a:r>
-              <a:rPr lang="en-US" smtClean="0"/>
+              <a:rPr lang="en-US"/>
               <a:t>Click to edit Master title style</a:t>
             </a:r>
             <a:endParaRPr lang="en-US" dirty="0"/>
@@ -285,7 +306,7 @@
           </a:lstStyle>
           <a:p>
             <a:r>
-              <a:rPr lang="en-US" smtClean="0"/>
+              <a:rPr lang="en-US"/>
               <a:t>Click to edit Master subtitle style</a:t>
             </a:r>
             <a:endParaRPr lang="en-US" dirty="0"/>
@@ -309,7 +330,7 @@
           <a:p>
             <a:fld id="{4AAD347D-5ACD-4C99-B74B-A9C85AD731AF}" type="datetimeFigureOut">
               <a:rPr lang="en-US" dirty="0"/>
-              <a:t>9/28/2024</a:t>
+              <a:t>11/27/2024</a:t>
             </a:fld>
             <a:endParaRPr lang="en-US" dirty="0"/>
           </a:p>
@@ -409,7 +430,7 @@
           </a:lstStyle>
           <a:p>
             <a:r>
-              <a:rPr lang="en-US" smtClean="0"/>
+              <a:rPr lang="en-US"/>
               <a:t>Click to edit Master title style</a:t>
             </a:r>
             <a:endParaRPr lang="en-US" dirty="0"/>
@@ -488,7 +509,7 @@
           </a:lstStyle>
           <a:p>
             <a:r>
-              <a:rPr lang="en-US" smtClean="0"/>
+              <a:rPr lang="en-US"/>
               <a:t>Click icon to add picture</a:t>
             </a:r>
             <a:endParaRPr lang="en-US" dirty="0"/>
@@ -556,7 +577,7 @@
           <a:p>
             <a:pPr lvl="0"/>
             <a:r>
-              <a:rPr lang="en-US" smtClean="0"/>
+              <a:rPr lang="en-US"/>
               <a:t>Edit Master text styles</a:t>
             </a:r>
           </a:p>
@@ -579,7 +600,7 @@
           <a:p>
             <a:fld id="{4509A250-FF31-4206-8172-F9D3106AACB1}" type="datetimeFigureOut">
               <a:rPr lang="en-US" dirty="0"/>
-              <a:t>9/28/2024</a:t>
+              <a:t>11/27/2024</a:t>
             </a:fld>
             <a:endParaRPr lang="en-US" dirty="0"/>
           </a:p>
@@ -677,7 +698,7 @@
           </a:lstStyle>
           <a:p>
             <a:r>
-              <a:rPr lang="en-US" smtClean="0"/>
+              <a:rPr lang="en-US"/>
               <a:t>Click to edit Master title style</a:t>
             </a:r>
             <a:endParaRPr lang="en-US" dirty="0"/>
@@ -745,7 +766,7 @@
           <a:p>
             <a:pPr lvl="0"/>
             <a:r>
-              <a:rPr lang="en-US" smtClean="0"/>
+              <a:rPr lang="en-US"/>
               <a:t>Edit Master text styles</a:t>
             </a:r>
           </a:p>
@@ -768,7 +789,7 @@
           <a:p>
             <a:fld id="{4509A250-FF31-4206-8172-F9D3106AACB1}" type="datetimeFigureOut">
               <a:rPr lang="en-US" dirty="0"/>
-              <a:t>9/28/2024</a:t>
+              <a:t>11/27/2024</a:t>
             </a:fld>
             <a:endParaRPr lang="en-US" dirty="0"/>
           </a:p>
@@ -866,7 +887,7 @@
           </a:lstStyle>
           <a:p>
             <a:r>
-              <a:rPr lang="en-US" smtClean="0"/>
+              <a:rPr lang="en-US"/>
               <a:t>Click to edit Master title style</a:t>
             </a:r>
             <a:endParaRPr lang="en-US" dirty="0"/>
@@ -944,7 +965,7 @@
           <a:p>
             <a:pPr lvl="0"/>
             <a:r>
-              <a:rPr lang="en-US" smtClean="0"/>
+              <a:rPr lang="en-US"/>
               <a:t>Edit Master text styles</a:t>
             </a:r>
           </a:p>
@@ -1011,7 +1032,7 @@
           <a:p>
             <a:pPr lvl="0"/>
             <a:r>
-              <a:rPr lang="en-US" smtClean="0"/>
+              <a:rPr lang="en-US"/>
               <a:t>Edit Master text styles</a:t>
             </a:r>
           </a:p>
@@ -1034,7 +1055,7 @@
           <a:p>
             <a:fld id="{4509A250-FF31-4206-8172-F9D3106AACB1}" type="datetimeFigureOut">
               <a:rPr lang="en-US" dirty="0"/>
-              <a:t>9/28/2024</a:t>
+              <a:t>11/27/2024</a:t>
             </a:fld>
             <a:endParaRPr lang="en-US" dirty="0"/>
           </a:p>
@@ -1212,7 +1233,7 @@
           </a:lstStyle>
           <a:p>
             <a:r>
-              <a:rPr lang="en-US" smtClean="0"/>
+              <a:rPr lang="en-US"/>
               <a:t>Click to edit Master title style</a:t>
             </a:r>
             <a:endParaRPr lang="en-US" dirty="0"/>
@@ -1333,7 +1354,7 @@
           <a:p>
             <a:pPr lvl="0"/>
             <a:r>
-              <a:rPr lang="en-US" smtClean="0"/>
+              <a:rPr lang="en-US"/>
               <a:t>Edit Master text styles</a:t>
             </a:r>
           </a:p>
@@ -1356,7 +1377,7 @@
           <a:p>
             <a:fld id="{4509A250-FF31-4206-8172-F9D3106AACB1}" type="datetimeFigureOut">
               <a:rPr lang="en-US" dirty="0"/>
-              <a:t>9/28/2024</a:t>
+              <a:t>11/27/2024</a:t>
             </a:fld>
             <a:endParaRPr lang="en-US" dirty="0"/>
           </a:p>
@@ -1449,7 +1470,7 @@
           </a:lstStyle>
           <a:p>
             <a:r>
-              <a:rPr lang="en-US" smtClean="0"/>
+              <a:rPr lang="en-US"/>
               <a:t>Click to edit Master title style</a:t>
             </a:r>
             <a:endParaRPr lang="en-US" dirty="0"/>
@@ -1524,7 +1545,7 @@
           <a:p>
             <a:pPr lvl="0"/>
             <a:r>
-              <a:rPr lang="en-US" smtClean="0"/>
+              <a:rPr lang="en-US"/>
               <a:t>Edit Master text styles</a:t>
             </a:r>
           </a:p>
@@ -1591,7 +1612,7 @@
           <a:p>
             <a:pPr lvl="0"/>
             <a:r>
-              <a:rPr lang="en-US" smtClean="0"/>
+              <a:rPr lang="en-US"/>
               <a:t>Edit Master text styles</a:t>
             </a:r>
           </a:p>
@@ -1665,7 +1686,7 @@
           <a:p>
             <a:pPr lvl="0"/>
             <a:r>
-              <a:rPr lang="en-US" smtClean="0"/>
+              <a:rPr lang="en-US"/>
               <a:t>Edit Master text styles</a:t>
             </a:r>
           </a:p>
@@ -1732,7 +1753,7 @@
           <a:p>
             <a:pPr lvl="0"/>
             <a:r>
-              <a:rPr lang="en-US" smtClean="0"/>
+              <a:rPr lang="en-US"/>
               <a:t>Edit Master text styles</a:t>
             </a:r>
           </a:p>
@@ -1806,7 +1827,7 @@
           <a:p>
             <a:pPr lvl="0"/>
             <a:r>
-              <a:rPr lang="en-US" smtClean="0"/>
+              <a:rPr lang="en-US"/>
               <a:t>Edit Master text styles</a:t>
             </a:r>
           </a:p>
@@ -1873,7 +1894,7 @@
           <a:p>
             <a:pPr lvl="0"/>
             <a:r>
-              <a:rPr lang="en-US" smtClean="0"/>
+              <a:rPr lang="en-US"/>
               <a:t>Edit Master text styles</a:t>
             </a:r>
           </a:p>
@@ -1970,7 +1991,7 @@
           <a:p>
             <a:fld id="{4509A250-FF31-4206-8172-F9D3106AACB1}" type="datetimeFigureOut">
               <a:rPr lang="en-US" dirty="0"/>
-              <a:t>9/28/2024</a:t>
+              <a:t>11/27/2024</a:t>
             </a:fld>
             <a:endParaRPr lang="en-US" dirty="0"/>
           </a:p>
@@ -2063,7 +2084,7 @@
           </a:lstStyle>
           <a:p>
             <a:r>
-              <a:rPr lang="en-US" smtClean="0"/>
+              <a:rPr lang="en-US"/>
               <a:t>Click to edit Master title style</a:t>
             </a:r>
             <a:endParaRPr lang="en-US" dirty="0"/>
@@ -2135,7 +2156,7 @@
           <a:p>
             <a:pPr lvl="0"/>
             <a:r>
-              <a:rPr lang="en-US" smtClean="0"/>
+              <a:rPr lang="en-US"/>
               <a:t>Edit Master text styles</a:t>
             </a:r>
           </a:p>
@@ -2213,7 +2234,7 @@
           </a:lstStyle>
           <a:p>
             <a:r>
-              <a:rPr lang="en-US" smtClean="0"/>
+              <a:rPr lang="en-US"/>
               <a:t>Click icon to add picture</a:t>
             </a:r>
             <a:endParaRPr lang="en-US" dirty="0"/>
@@ -2281,7 +2302,7 @@
           <a:p>
             <a:pPr lvl="0"/>
             <a:r>
-              <a:rPr lang="en-US" smtClean="0"/>
+              <a:rPr lang="en-US"/>
               <a:t>Edit Master text styles</a:t>
             </a:r>
           </a:p>
@@ -2352,7 +2373,7 @@
           <a:p>
             <a:pPr lvl="0"/>
             <a:r>
-              <a:rPr lang="en-US" smtClean="0"/>
+              <a:rPr lang="en-US"/>
               <a:t>Edit Master text styles</a:t>
             </a:r>
           </a:p>
@@ -2430,7 +2451,7 @@
           </a:lstStyle>
           <a:p>
             <a:r>
-              <a:rPr lang="en-US" smtClean="0"/>
+              <a:rPr lang="en-US"/>
               <a:t>Click icon to add picture</a:t>
             </a:r>
             <a:endParaRPr lang="en-US" dirty="0"/>
@@ -2498,7 +2519,7 @@
           <a:p>
             <a:pPr lvl="0"/>
             <a:r>
-              <a:rPr lang="en-US" smtClean="0"/>
+              <a:rPr lang="en-US"/>
               <a:t>Edit Master text styles</a:t>
             </a:r>
           </a:p>
@@ -2569,7 +2590,7 @@
           <a:p>
             <a:pPr lvl="0"/>
             <a:r>
-              <a:rPr lang="en-US" smtClean="0"/>
+              <a:rPr lang="en-US"/>
               <a:t>Edit Master text styles</a:t>
             </a:r>
           </a:p>
@@ -2647,7 +2668,7 @@
           </a:lstStyle>
           <a:p>
             <a:r>
-              <a:rPr lang="en-US" smtClean="0"/>
+              <a:rPr lang="en-US"/>
               <a:t>Click icon to add picture</a:t>
             </a:r>
             <a:endParaRPr lang="en-US" dirty="0"/>
@@ -2715,7 +2736,7 @@
           <a:p>
             <a:pPr lvl="0"/>
             <a:r>
-              <a:rPr lang="en-US" smtClean="0"/>
+              <a:rPr lang="en-US"/>
               <a:t>Edit Master text styles</a:t>
             </a:r>
           </a:p>
@@ -2812,7 +2833,7 @@
           <a:p>
             <a:fld id="{4509A250-FF31-4206-8172-F9D3106AACB1}" type="datetimeFigureOut">
               <a:rPr lang="en-US" dirty="0"/>
-              <a:t>9/28/2024</a:t>
+              <a:t>11/27/2024</a:t>
             </a:fld>
             <a:endParaRPr lang="en-US" dirty="0"/>
           </a:p>
@@ -2901,7 +2922,7 @@
           <a:lstStyle/>
           <a:p>
             <a:r>
-              <a:rPr lang="en-US" smtClean="0"/>
+              <a:rPr lang="en-US"/>
               <a:t>Click to edit Master title style</a:t>
             </a:r>
             <a:endParaRPr lang="en-US" dirty="0"/>
@@ -2925,35 +2946,35 @@
           <a:p>
             <a:pPr lvl="0"/>
             <a:r>
-              <a:rPr lang="en-US" smtClean="0"/>
+              <a:rPr lang="en-US"/>
               <a:t>Edit Master text styles</a:t>
             </a:r>
           </a:p>
           <a:p>
             <a:pPr lvl="1"/>
             <a:r>
-              <a:rPr lang="en-US" smtClean="0"/>
+              <a:rPr lang="en-US"/>
               <a:t>Second level</a:t>
             </a:r>
           </a:p>
           <a:p>
             <a:pPr lvl="2"/>
             <a:r>
-              <a:rPr lang="en-US" smtClean="0"/>
+              <a:rPr lang="en-US"/>
               <a:t>Third level</a:t>
             </a:r>
           </a:p>
           <a:p>
             <a:pPr lvl="3"/>
             <a:r>
-              <a:rPr lang="en-US" smtClean="0"/>
+              <a:rPr lang="en-US"/>
               <a:t>Fourth level</a:t>
             </a:r>
           </a:p>
           <a:p>
             <a:pPr lvl="4"/>
             <a:r>
-              <a:rPr lang="en-US" smtClean="0"/>
+              <a:rPr lang="en-US"/>
               <a:t>Fifth level</a:t>
             </a:r>
             <a:endParaRPr lang="en-US" dirty="0"/>
@@ -2977,7 +2998,7 @@
           <a:p>
             <a:fld id="{4509A250-FF31-4206-8172-F9D3106AACB1}" type="datetimeFigureOut">
               <a:rPr lang="en-US" dirty="0"/>
-              <a:t>9/28/2024</a:t>
+              <a:t>11/27/2024</a:t>
             </a:fld>
             <a:endParaRPr lang="en-US" dirty="0"/>
           </a:p>
@@ -3071,7 +3092,7 @@
           <a:lstStyle/>
           <a:p>
             <a:r>
-              <a:rPr lang="en-US" smtClean="0"/>
+              <a:rPr lang="en-US"/>
               <a:t>Click to edit Master title style</a:t>
             </a:r>
             <a:endParaRPr lang="en-US" dirty="0"/>
@@ -3100,35 +3121,35 @@
           <a:p>
             <a:pPr lvl="0"/>
             <a:r>
-              <a:rPr lang="en-US" smtClean="0"/>
+              <a:rPr lang="en-US"/>
               <a:t>Edit Master text styles</a:t>
             </a:r>
           </a:p>
           <a:p>
             <a:pPr lvl="1"/>
             <a:r>
-              <a:rPr lang="en-US" smtClean="0"/>
+              <a:rPr lang="en-US"/>
               <a:t>Second level</a:t>
             </a:r>
           </a:p>
           <a:p>
             <a:pPr lvl="2"/>
             <a:r>
-              <a:rPr lang="en-US" smtClean="0"/>
+              <a:rPr lang="en-US"/>
               <a:t>Third level</a:t>
             </a:r>
           </a:p>
           <a:p>
             <a:pPr lvl="3"/>
             <a:r>
-              <a:rPr lang="en-US" smtClean="0"/>
+              <a:rPr lang="en-US"/>
               <a:t>Fourth level</a:t>
             </a:r>
           </a:p>
           <a:p>
             <a:pPr lvl="4"/>
             <a:r>
-              <a:rPr lang="en-US" smtClean="0"/>
+              <a:rPr lang="en-US"/>
               <a:t>Fifth level</a:t>
             </a:r>
             <a:endParaRPr lang="en-US" dirty="0"/>
@@ -3152,7 +3173,7 @@
           <a:p>
             <a:fld id="{4509A250-FF31-4206-8172-F9D3106AACB1}" type="datetimeFigureOut">
               <a:rPr lang="en-US" dirty="0"/>
-              <a:t>9/28/2024</a:t>
+              <a:t>11/27/2024</a:t>
             </a:fld>
             <a:endParaRPr lang="en-US" dirty="0"/>
           </a:p>
@@ -3241,7 +3262,7 @@
           <a:lstStyle/>
           <a:p>
             <a:r>
-              <a:rPr lang="en-US" smtClean="0"/>
+              <a:rPr lang="en-US"/>
               <a:t>Click to edit Master title style</a:t>
             </a:r>
             <a:endParaRPr lang="en-US" dirty="0"/>
@@ -3265,35 +3286,35 @@
           <a:p>
             <a:pPr lvl="0"/>
             <a:r>
-              <a:rPr lang="en-US" smtClean="0"/>
+              <a:rPr lang="en-US"/>
               <a:t>Edit Master text styles</a:t>
             </a:r>
           </a:p>
           <a:p>
             <a:pPr lvl="1"/>
             <a:r>
-              <a:rPr lang="en-US" smtClean="0"/>
+              <a:rPr lang="en-US"/>
               <a:t>Second level</a:t>
             </a:r>
           </a:p>
           <a:p>
             <a:pPr lvl="2"/>
             <a:r>
-              <a:rPr lang="en-US" smtClean="0"/>
+              <a:rPr lang="en-US"/>
               <a:t>Third level</a:t>
             </a:r>
           </a:p>
           <a:p>
             <a:pPr lvl="3"/>
             <a:r>
-              <a:rPr lang="en-US" smtClean="0"/>
+              <a:rPr lang="en-US"/>
               <a:t>Fourth level</a:t>
             </a:r>
           </a:p>
           <a:p>
             <a:pPr lvl="4"/>
             <a:r>
-              <a:rPr lang="en-US" smtClean="0"/>
+              <a:rPr lang="en-US"/>
               <a:t>Fifth level</a:t>
             </a:r>
             <a:endParaRPr lang="en-US" dirty="0"/>
@@ -3317,7 +3338,7 @@
           <a:p>
             <a:fld id="{9796027F-7875-4030-9381-8BD8C4F21935}" type="datetimeFigureOut">
               <a:rPr lang="en-US" dirty="0"/>
-              <a:t>9/28/2024</a:t>
+              <a:t>11/27/2024</a:t>
             </a:fld>
             <a:endParaRPr lang="en-US" dirty="0"/>
           </a:p>
@@ -3415,7 +3436,7 @@
           </a:lstStyle>
           <a:p>
             <a:r>
-              <a:rPr lang="en-US" smtClean="0"/>
+              <a:rPr lang="en-US"/>
               <a:t>Click to edit Master title style</a:t>
             </a:r>
             <a:endParaRPr lang="en-US" dirty="0"/>
@@ -3536,7 +3557,7 @@
           <a:p>
             <a:pPr lvl="0"/>
             <a:r>
-              <a:rPr lang="en-US" smtClean="0"/>
+              <a:rPr lang="en-US"/>
               <a:t>Edit Master text styles</a:t>
             </a:r>
           </a:p>
@@ -3559,7 +3580,7 @@
           <a:p>
             <a:fld id="{9796027F-7875-4030-9381-8BD8C4F21935}" type="datetimeFigureOut">
               <a:rPr lang="en-US" dirty="0"/>
-              <a:t>9/28/2024</a:t>
+              <a:t>11/27/2024</a:t>
             </a:fld>
             <a:endParaRPr lang="en-US" dirty="0"/>
           </a:p>
@@ -3648,7 +3669,7 @@
           <a:lstStyle/>
           <a:p>
             <a:r>
-              <a:rPr lang="en-US" smtClean="0"/>
+              <a:rPr lang="en-US"/>
               <a:t>Click to edit Master title style</a:t>
             </a:r>
             <a:endParaRPr lang="en-US" dirty="0"/>
@@ -3707,35 +3728,35 @@
           <a:p>
             <a:pPr lvl="0"/>
             <a:r>
-              <a:rPr lang="en-US" smtClean="0"/>
+              <a:rPr lang="en-US"/>
               <a:t>Edit Master text styles</a:t>
             </a:r>
           </a:p>
           <a:p>
             <a:pPr lvl="1"/>
             <a:r>
-              <a:rPr lang="en-US" smtClean="0"/>
+              <a:rPr lang="en-US"/>
               <a:t>Second level</a:t>
             </a:r>
           </a:p>
           <a:p>
             <a:pPr lvl="2"/>
             <a:r>
-              <a:rPr lang="en-US" smtClean="0"/>
+              <a:rPr lang="en-US"/>
               <a:t>Third level</a:t>
             </a:r>
           </a:p>
           <a:p>
             <a:pPr lvl="3"/>
             <a:r>
-              <a:rPr lang="en-US" smtClean="0"/>
+              <a:rPr lang="en-US"/>
               <a:t>Fourth level</a:t>
             </a:r>
           </a:p>
           <a:p>
             <a:pPr lvl="4"/>
             <a:r>
-              <a:rPr lang="en-US" smtClean="0"/>
+              <a:rPr lang="en-US"/>
               <a:t>Fifth level</a:t>
             </a:r>
             <a:endParaRPr lang="en-US" dirty="0"/>
@@ -3794,35 +3815,35 @@
           <a:p>
             <a:pPr lvl="0"/>
             <a:r>
-              <a:rPr lang="en-US" smtClean="0"/>
+              <a:rPr lang="en-US"/>
               <a:t>Edit Master text styles</a:t>
             </a:r>
           </a:p>
           <a:p>
             <a:pPr lvl="1"/>
             <a:r>
-              <a:rPr lang="en-US" smtClean="0"/>
+              <a:rPr lang="en-US"/>
               <a:t>Second level</a:t>
             </a:r>
           </a:p>
           <a:p>
             <a:pPr lvl="2"/>
             <a:r>
-              <a:rPr lang="en-US" smtClean="0"/>
+              <a:rPr lang="en-US"/>
               <a:t>Third level</a:t>
             </a:r>
           </a:p>
           <a:p>
             <a:pPr lvl="3"/>
             <a:r>
-              <a:rPr lang="en-US" smtClean="0"/>
+              <a:rPr lang="en-US"/>
               <a:t>Fourth level</a:t>
             </a:r>
           </a:p>
           <a:p>
             <a:pPr lvl="4"/>
             <a:r>
-              <a:rPr lang="en-US" smtClean="0"/>
+              <a:rPr lang="en-US"/>
               <a:t>Fifth level</a:t>
             </a:r>
             <a:endParaRPr lang="en-US" dirty="0"/>
@@ -3846,7 +3867,7 @@
           <a:p>
             <a:fld id="{9796027F-7875-4030-9381-8BD8C4F21935}" type="datetimeFigureOut">
               <a:rPr lang="en-US" dirty="0"/>
-              <a:t>9/28/2024</a:t>
+              <a:t>11/27/2024</a:t>
             </a:fld>
             <a:endParaRPr lang="en-US" dirty="0"/>
           </a:p>
@@ -3939,7 +3960,7 @@
           </a:lstStyle>
           <a:p>
             <a:r>
-              <a:rPr lang="en-US" smtClean="0"/>
+              <a:rPr lang="en-US"/>
               <a:t>Click to edit Master title style</a:t>
             </a:r>
             <a:endParaRPr lang="en-US" dirty="0"/>
@@ -4014,7 +4035,7 @@
           <a:p>
             <a:pPr lvl="0"/>
             <a:r>
-              <a:rPr lang="en-US" smtClean="0"/>
+              <a:rPr lang="en-US"/>
               <a:t>Edit Master text styles</a:t>
             </a:r>
           </a:p>
@@ -4072,35 +4093,35 @@
           <a:p>
             <a:pPr lvl="0"/>
             <a:r>
-              <a:rPr lang="en-US" smtClean="0"/>
+              <a:rPr lang="en-US"/>
               <a:t>Edit Master text styles</a:t>
             </a:r>
           </a:p>
           <a:p>
             <a:pPr lvl="1"/>
             <a:r>
-              <a:rPr lang="en-US" smtClean="0"/>
+              <a:rPr lang="en-US"/>
               <a:t>Second level</a:t>
             </a:r>
           </a:p>
           <a:p>
             <a:pPr lvl="2"/>
             <a:r>
-              <a:rPr lang="en-US" smtClean="0"/>
+              <a:rPr lang="en-US"/>
               <a:t>Third level</a:t>
             </a:r>
           </a:p>
           <a:p>
             <a:pPr lvl="3"/>
             <a:r>
-              <a:rPr lang="en-US" smtClean="0"/>
+              <a:rPr lang="en-US"/>
               <a:t>Fourth level</a:t>
             </a:r>
           </a:p>
           <a:p>
             <a:pPr lvl="4"/>
             <a:r>
-              <a:rPr lang="en-US" smtClean="0"/>
+              <a:rPr lang="en-US"/>
               <a:t>Fifth level</a:t>
             </a:r>
             <a:endParaRPr lang="en-US" dirty="0"/>
@@ -4175,7 +4196,7 @@
           <a:p>
             <a:pPr lvl="0"/>
             <a:r>
-              <a:rPr lang="en-US" smtClean="0"/>
+              <a:rPr lang="en-US"/>
               <a:t>Edit Master text styles</a:t>
             </a:r>
           </a:p>
@@ -4233,35 +4254,35 @@
           <a:p>
             <a:pPr lvl="0"/>
             <a:r>
-              <a:rPr lang="en-US" smtClean="0"/>
+              <a:rPr lang="en-US"/>
               <a:t>Edit Master text styles</a:t>
             </a:r>
           </a:p>
           <a:p>
             <a:pPr lvl="1"/>
             <a:r>
-              <a:rPr lang="en-US" smtClean="0"/>
+              <a:rPr lang="en-US"/>
               <a:t>Second level</a:t>
             </a:r>
           </a:p>
           <a:p>
             <a:pPr lvl="2"/>
             <a:r>
-              <a:rPr lang="en-US" smtClean="0"/>
+              <a:rPr lang="en-US"/>
               <a:t>Third level</a:t>
             </a:r>
           </a:p>
           <a:p>
             <a:pPr lvl="3"/>
             <a:r>
-              <a:rPr lang="en-US" smtClean="0"/>
+              <a:rPr lang="en-US"/>
               <a:t>Fourth level</a:t>
             </a:r>
           </a:p>
           <a:p>
             <a:pPr lvl="4"/>
             <a:r>
-              <a:rPr lang="en-US" smtClean="0"/>
+              <a:rPr lang="en-US"/>
               <a:t>Fifth level</a:t>
             </a:r>
             <a:endParaRPr lang="en-US" dirty="0"/>
@@ -4285,7 +4306,7 @@
           <a:p>
             <a:fld id="{9796027F-7875-4030-9381-8BD8C4F21935}" type="datetimeFigureOut">
               <a:rPr lang="en-US" dirty="0"/>
-              <a:t>9/28/2024</a:t>
+              <a:t>11/27/2024</a:t>
             </a:fld>
             <a:endParaRPr lang="en-US" dirty="0"/>
           </a:p>
@@ -4374,7 +4395,7 @@
           <a:lstStyle/>
           <a:p>
             <a:r>
-              <a:rPr lang="en-US" smtClean="0"/>
+              <a:rPr lang="en-US"/>
               <a:t>Click to edit Master title style</a:t>
             </a:r>
             <a:endParaRPr lang="en-US" dirty="0"/>
@@ -4398,7 +4419,7 @@
           <a:p>
             <a:fld id="{4509A250-FF31-4206-8172-F9D3106AACB1}" type="datetimeFigureOut">
               <a:rPr lang="en-US" dirty="0"/>
-              <a:t>9/28/2024</a:t>
+              <a:t>11/27/2024</a:t>
             </a:fld>
             <a:endParaRPr lang="en-US" dirty="0"/>
           </a:p>
@@ -4488,7 +4509,7 @@
           <a:p>
             <a:fld id="{4509A250-FF31-4206-8172-F9D3106AACB1}" type="datetimeFigureOut">
               <a:rPr lang="en-US" dirty="0"/>
-              <a:t>9/28/2024</a:t>
+              <a:t>11/27/2024</a:t>
             </a:fld>
             <a:endParaRPr lang="en-US" dirty="0"/>
           </a:p>
@@ -4586,7 +4607,7 @@
           </a:lstStyle>
           <a:p>
             <a:r>
-              <a:rPr lang="en-US" smtClean="0"/>
+              <a:rPr lang="en-US"/>
               <a:t>Click to edit Master title style</a:t>
             </a:r>
             <a:endParaRPr lang="en-US" dirty="0"/>
@@ -4645,35 +4666,35 @@
           <a:p>
             <a:pPr lvl="0"/>
             <a:r>
-              <a:rPr lang="en-US" smtClean="0"/>
+              <a:rPr lang="en-US"/>
               <a:t>Edit Master text styles</a:t>
             </a:r>
           </a:p>
           <a:p>
             <a:pPr lvl="1"/>
             <a:r>
-              <a:rPr lang="en-US" smtClean="0"/>
+              <a:rPr lang="en-US"/>
               <a:t>Second level</a:t>
             </a:r>
           </a:p>
           <a:p>
             <a:pPr lvl="2"/>
             <a:r>
-              <a:rPr lang="en-US" smtClean="0"/>
+              <a:rPr lang="en-US"/>
               <a:t>Third level</a:t>
             </a:r>
           </a:p>
           <a:p>
             <a:pPr lvl="3"/>
             <a:r>
-              <a:rPr lang="en-US" smtClean="0"/>
+              <a:rPr lang="en-US"/>
               <a:t>Fourth level</a:t>
             </a:r>
           </a:p>
           <a:p>
             <a:pPr lvl="4"/>
             <a:r>
-              <a:rPr lang="en-US" smtClean="0"/>
+              <a:rPr lang="en-US"/>
               <a:t>Fifth level</a:t>
             </a:r>
             <a:endParaRPr lang="en-US" dirty="0"/>
@@ -4739,7 +4760,7 @@
           <a:p>
             <a:pPr lvl="0"/>
             <a:r>
-              <a:rPr lang="en-US" smtClean="0"/>
+              <a:rPr lang="en-US"/>
               <a:t>Edit Master text styles</a:t>
             </a:r>
           </a:p>
@@ -4762,7 +4783,7 @@
           <a:p>
             <a:fld id="{4509A250-FF31-4206-8172-F9D3106AACB1}" type="datetimeFigureOut">
               <a:rPr lang="en-US" dirty="0"/>
-              <a:t>9/28/2024</a:t>
+              <a:t>11/27/2024</a:t>
             </a:fld>
             <a:endParaRPr lang="en-US" dirty="0"/>
           </a:p>
@@ -4862,7 +4883,7 @@
           </a:lstStyle>
           <a:p>
             <a:r>
-              <a:rPr lang="en-US" smtClean="0"/>
+              <a:rPr lang="en-US"/>
               <a:t>Click to edit Master title style</a:t>
             </a:r>
             <a:endParaRPr lang="en-US" dirty="0"/>
@@ -4941,7 +4962,7 @@
           </a:lstStyle>
           <a:p>
             <a:r>
-              <a:rPr lang="en-US" smtClean="0"/>
+              <a:rPr lang="en-US"/>
               <a:t>Click icon to add picture</a:t>
             </a:r>
             <a:endParaRPr lang="en-US" dirty="0"/>
@@ -5009,7 +5030,7 @@
           <a:p>
             <a:pPr lvl="0"/>
             <a:r>
-              <a:rPr lang="en-US" smtClean="0"/>
+              <a:rPr lang="en-US"/>
               <a:t>Edit Master text styles</a:t>
             </a:r>
           </a:p>
@@ -5032,7 +5053,7 @@
           <a:p>
             <a:fld id="{4509A250-FF31-4206-8172-F9D3106AACB1}" type="datetimeFigureOut">
               <a:rPr lang="en-US" dirty="0"/>
-              <a:t>9/28/2024</a:t>
+              <a:t>11/27/2024</a:t>
             </a:fld>
             <a:endParaRPr lang="en-US" dirty="0"/>
           </a:p>
@@ -5345,7 +5366,7 @@
           <a:lstStyle/>
           <a:p>
             <a:r>
-              <a:rPr lang="en-US" smtClean="0"/>
+              <a:rPr lang="en-US"/>
               <a:t>Click to edit Master title style</a:t>
             </a:r>
             <a:endParaRPr lang="en-US" dirty="0"/>
@@ -5379,35 +5400,35 @@
           <a:p>
             <a:pPr lvl="0"/>
             <a:r>
-              <a:rPr lang="en-US" smtClean="0"/>
+              <a:rPr lang="en-US"/>
               <a:t>Edit Master text styles</a:t>
             </a:r>
           </a:p>
           <a:p>
             <a:pPr lvl="1"/>
             <a:r>
-              <a:rPr lang="en-US" smtClean="0"/>
+              <a:rPr lang="en-US"/>
               <a:t>Second level</a:t>
             </a:r>
           </a:p>
           <a:p>
             <a:pPr lvl="2"/>
             <a:r>
-              <a:rPr lang="en-US" smtClean="0"/>
+              <a:rPr lang="en-US"/>
               <a:t>Third level</a:t>
             </a:r>
           </a:p>
           <a:p>
             <a:pPr lvl="3"/>
             <a:r>
-              <a:rPr lang="en-US" smtClean="0"/>
+              <a:rPr lang="en-US"/>
               <a:t>Fourth level</a:t>
             </a:r>
           </a:p>
           <a:p>
             <a:pPr lvl="4"/>
             <a:r>
-              <a:rPr lang="en-US" smtClean="0"/>
+              <a:rPr lang="en-US"/>
               <a:t>Fifth level</a:t>
             </a:r>
             <a:endParaRPr lang="en-US" dirty="0"/>
@@ -5450,7 +5471,7 @@
           <a:p>
             <a:fld id="{4AAD347D-5ACD-4C99-B74B-A9C85AD731AF}" type="datetimeFigureOut">
               <a:rPr lang="en-US" dirty="0"/>
-              <a:t>9/28/2024</a:t>
+              <a:t>11/27/2024</a:t>
             </a:fld>
             <a:endParaRPr lang="en-US" dirty="0"/>
           </a:p>
@@ -5990,10 +6011,9 @@
           <a:lstStyle/>
           <a:p>
             <a:r>
-              <a:rPr lang="en-US" dirty="0" smtClean="0"/>
+              <a:rPr lang="en-US" dirty="0"/>
               <a:t>Software Design Patterns</a:t>
             </a:r>
-            <a:endParaRPr lang="en-US" dirty="0"/>
           </a:p>
         </p:txBody>
       </p:sp>
@@ -6012,7 +6032,18 @@
           <a:bodyPr/>
           <a:lstStyle/>
           <a:p>
-            <a:endParaRPr lang="en-US"/>
+            <a:r>
+              <a:rPr lang="en-US" dirty="0"/>
+              <a:t>SJC </a:t>
+            </a:r>
+            <a:r>
+              <a:rPr lang="en-US" dirty="0" err="1"/>
+              <a:t>Institue</a:t>
+            </a:r>
+            <a:r>
+              <a:rPr lang="en-US" dirty="0"/>
+              <a:t> of technology</a:t>
+            </a:r>
           </a:p>
         </p:txBody>
       </p:sp>
@@ -6062,10 +6093,9 @@
           <a:lstStyle/>
           <a:p>
             <a:r>
-              <a:rPr lang="en-US" dirty="0" smtClean="0"/>
+              <a:rPr lang="en-US" dirty="0"/>
               <a:t>Singleton Design Pattern(Creational Design Pattern)</a:t>
             </a:r>
-            <a:endParaRPr lang="en-US" dirty="0"/>
           </a:p>
         </p:txBody>
       </p:sp>
@@ -6085,42 +6115,41 @@
           <a:lstStyle/>
           <a:p>
             <a:r>
-              <a:rPr lang="en-US" dirty="0" smtClean="0"/>
+              <a:rPr lang="en-US" dirty="0"/>
               <a:t>Singleton mean: we create single instance(object) for a particular class. Here we need to ensure no other instance(object) are created for that respective class.</a:t>
             </a:r>
           </a:p>
           <a:p>
             <a:r>
-              <a:rPr lang="en-US" dirty="0" smtClean="0"/>
+              <a:rPr lang="en-US" dirty="0"/>
               <a:t>USE CASE:</a:t>
             </a:r>
           </a:p>
           <a:p>
             <a:r>
-              <a:rPr lang="en-US" dirty="0" smtClean="0"/>
+              <a:rPr lang="en-US" dirty="0"/>
               <a:t>1. DB Creation: In project, we need only one </a:t>
             </a:r>
             <a:r>
-              <a:rPr lang="en-US" dirty="0" err="1" smtClean="0"/>
+              <a:rPr lang="en-US" dirty="0" err="1"/>
               <a:t>db</a:t>
             </a:r>
             <a:r>
-              <a:rPr lang="en-US" dirty="0" smtClean="0"/>
+              <a:rPr lang="en-US" dirty="0"/>
               <a:t> connect for all the modules of your project.</a:t>
             </a:r>
           </a:p>
           <a:p>
             <a:r>
-              <a:rPr lang="en-US" dirty="0" smtClean="0"/>
+              <a:rPr lang="en-US" dirty="0"/>
               <a:t>2.UT(unit test) Manager: a single manager file handle to run all UT’s at a time.</a:t>
             </a:r>
           </a:p>
           <a:p>
             <a:r>
-              <a:rPr lang="en-US" dirty="0" smtClean="0"/>
+              <a:rPr lang="en-US" dirty="0"/>
               <a:t>3. Logger manager: Instead of showing logs in different places, we can mange to show all logs in single place in our project</a:t>
             </a:r>
-            <a:endParaRPr lang="en-US" dirty="0"/>
           </a:p>
         </p:txBody>
       </p:sp>
@@ -6170,10 +6199,9 @@
           <a:lstStyle/>
           <a:p>
             <a:r>
-              <a:rPr lang="en-US" dirty="0" smtClean="0"/>
+              <a:rPr lang="en-US" dirty="0"/>
               <a:t>Singleton: Case Study</a:t>
             </a:r>
-            <a:endParaRPr lang="en-US" dirty="0"/>
           </a:p>
         </p:txBody>
       </p:sp>
@@ -6198,11 +6226,7 @@
             </a:r>
             <a:r>
               <a:rPr lang="en-US" dirty="0"/>
-              <a:t> and Implement a Logger class ensuring a single instance throughout the application</a:t>
-            </a:r>
-            <a:r>
-              <a:rPr lang="en-US" dirty="0" smtClean="0"/>
-              <a:t>?</a:t>
+              <a:t> and Implement a Logger class ensuring a single instance throughout the application?</a:t>
             </a:r>
           </a:p>
           <a:p>
@@ -6242,7 +6266,13 @@
       </p:grpSpPr>
       <p:sp>
         <p:nvSpPr>
-          <p:cNvPr id="2" name="Title 1"/>
+          <p:cNvPr id="2" name="Title 1">
+            <a:extLst>
+              <a:ext uri="{FF2B5EF4-FFF2-40B4-BE49-F238E27FC236}">
+                <a16:creationId xmlns:a16="http://schemas.microsoft.com/office/drawing/2014/main" id="{5AC17DEF-9B5B-9C14-D76E-30EA2DB28509}"/>
+              </a:ext>
+            </a:extLst>
+          </p:cNvPr>
           <p:cNvSpPr>
             <a:spLocks noGrp="1"/>
           </p:cNvSpPr>
@@ -6256,40 +6286,84 @@
           <a:lstStyle/>
           <a:p>
             <a:r>
-              <a:rPr lang="en-US" dirty="0" smtClean="0"/>
-              <a:t>Façade Design Pattern</a:t>
-            </a:r>
+              <a:rPr lang="en-IN" dirty="0"/>
+              <a:t>Factory Design Pattern</a:t>
+            </a:r>
+          </a:p>
+        </p:txBody>
+      </p:sp>
+      <p:sp>
+        <p:nvSpPr>
+          <p:cNvPr id="3" name="Content Placeholder 2">
+            <a:extLst>
+              <a:ext uri="{FF2B5EF4-FFF2-40B4-BE49-F238E27FC236}">
+                <a16:creationId xmlns:a16="http://schemas.microsoft.com/office/drawing/2014/main" id="{D3ED4E77-4BEE-FC61-E7CE-4855E9EE6F48}"/>
+              </a:ext>
+            </a:extLst>
+          </p:cNvPr>
+          <p:cNvSpPr>
+            <a:spLocks noGrp="1"/>
+          </p:cNvSpPr>
+          <p:nvPr>
+            <p:ph idx="1"/>
+          </p:nvPr>
+        </p:nvSpPr>
+        <p:spPr/>
+        <p:txBody>
+          <a:bodyPr/>
+          <a:lstStyle/>
+          <a:p>
+            <a:r>
+              <a:rPr lang="en-US" dirty="0"/>
+              <a:t>the Factory Design Pattern encapsulates the creation logic of different shape objects within the </a:t>
+            </a:r>
+            <a:r>
+              <a:rPr lang="en-US" dirty="0" err="1"/>
+              <a:t>ShapeFactory</a:t>
+            </a:r>
+            <a:r>
+              <a:rPr lang="en-US" dirty="0"/>
+              <a:t>. </a:t>
+            </a:r>
+          </a:p>
+          <a:p>
             <a:endParaRPr lang="en-US" dirty="0"/>
           </a:p>
         </p:txBody>
       </p:sp>
-      <p:sp>
-        <p:nvSpPr>
-          <p:cNvPr id="3" name="Content Placeholder 2"/>
-          <p:cNvSpPr>
-            <a:spLocks noGrp="1"/>
-          </p:cNvSpPr>
-          <p:nvPr>
-            <p:ph idx="1"/>
-          </p:nvPr>
-        </p:nvSpPr>
-        <p:spPr/>
-        <p:txBody>
-          <a:bodyPr/>
-          <a:lstStyle/>
-          <a:p>
-            <a:r>
-              <a:rPr lang="en-US" dirty="0" smtClean="0"/>
-              <a:t>“Provide a unified interface t</a:t>
-            </a:r>
-            <a:endParaRPr lang="en-US" dirty="0"/>
-          </a:p>
-        </p:txBody>
-      </p:sp>
+      <p:pic>
+        <p:nvPicPr>
+          <p:cNvPr id="5" name="Picture 4">
+            <a:extLst>
+              <a:ext uri="{FF2B5EF4-FFF2-40B4-BE49-F238E27FC236}">
+                <a16:creationId xmlns:a16="http://schemas.microsoft.com/office/drawing/2014/main" id="{57F3EA6B-C390-675E-7C10-15D74B3ED20F}"/>
+              </a:ext>
+            </a:extLst>
+          </p:cNvPr>
+          <p:cNvPicPr>
+            <a:picLocks noChangeAspect="1"/>
+          </p:cNvPicPr>
+          <p:nvPr/>
+        </p:nvPicPr>
+        <p:blipFill rotWithShape="1">
+          <a:blip r:embed="rId2"/>
+          <a:srcRect l="9414" r="9290"/>
+          <a:stretch/>
+        </p:blipFill>
+        <p:spPr>
+          <a:xfrm>
+            <a:off x="2958354" y="3092823"/>
+            <a:ext cx="5961530" cy="3155576"/>
+          </a:xfrm>
+          <a:prstGeom prst="rect">
+            <a:avLst/>
+          </a:prstGeom>
+        </p:spPr>
+      </p:pic>
     </p:spTree>
     <p:extLst>
       <p:ext uri="{BB962C8B-B14F-4D97-AF65-F5344CB8AC3E}">
-        <p14:creationId xmlns:p14="http://schemas.microsoft.com/office/powerpoint/2010/main" val="1180489966"/>
+        <p14:creationId xmlns:p14="http://schemas.microsoft.com/office/powerpoint/2010/main" val="3530181580"/>
       </p:ext>
     </p:extLst>
   </p:cSld>
@@ -6318,7 +6392,13 @@
       </p:grpSpPr>
       <p:sp>
         <p:nvSpPr>
-          <p:cNvPr id="2" name="Title 1"/>
+          <p:cNvPr id="2" name="Title 1">
+            <a:extLst>
+              <a:ext uri="{FF2B5EF4-FFF2-40B4-BE49-F238E27FC236}">
+                <a16:creationId xmlns:a16="http://schemas.microsoft.com/office/drawing/2014/main" id="{26CEA8C1-A493-6E0B-0751-7F8E12C97074}"/>
+              </a:ext>
+            </a:extLst>
+          </p:cNvPr>
           <p:cNvSpPr>
             <a:spLocks noGrp="1"/>
           </p:cNvSpPr>
@@ -6332,133 +6412,45 @@
           <a:lstStyle/>
           <a:p>
             <a:r>
-              <a:rPr lang="en-US" dirty="0" smtClean="0"/>
-              <a:t>Template Design Pattern</a:t>
-            </a:r>
-            <a:endParaRPr lang="en-US" dirty="0"/>
-          </a:p>
-        </p:txBody>
-      </p:sp>
-      <p:sp>
-        <p:nvSpPr>
-          <p:cNvPr id="3" name="Content Placeholder 2"/>
-          <p:cNvSpPr>
-            <a:spLocks noGrp="1"/>
-          </p:cNvSpPr>
+              <a:rPr lang="en-IN" dirty="0"/>
+              <a:t>Factory Design Pattern</a:t>
+            </a:r>
+          </a:p>
+        </p:txBody>
+      </p:sp>
+      <p:pic>
+        <p:nvPicPr>
+          <p:cNvPr id="5" name="Content Placeholder 4">
+            <a:extLst>
+              <a:ext uri="{FF2B5EF4-FFF2-40B4-BE49-F238E27FC236}">
+                <a16:creationId xmlns:a16="http://schemas.microsoft.com/office/drawing/2014/main" id="{2CEF4C47-A5FB-31F3-E9D4-5AC6FA065E5D}"/>
+              </a:ext>
+            </a:extLst>
+          </p:cNvPr>
+          <p:cNvPicPr>
+            <a:picLocks noGrp="1" noChangeAspect="1"/>
+          </p:cNvPicPr>
           <p:nvPr>
             <p:ph idx="1"/>
           </p:nvPr>
-        </p:nvSpPr>
-        <p:spPr/>
-        <p:txBody>
-          <a:bodyPr>
-            <a:normAutofit fontScale="85000" lnSpcReduction="20000"/>
-          </a:bodyPr>
-          <a:lstStyle/>
-          <a:p>
-            <a:r>
-              <a:rPr lang="en-US" dirty="0" smtClean="0"/>
-              <a:t>“</a:t>
-            </a:r>
-            <a:r>
-              <a:rPr lang="en-US" dirty="0"/>
-              <a:t>The Template Method pattern defines the skeleton of an algorithm in a method, deferring some steps to subclasses. It lets subclasses redefine certain steps of an algorithm without changing its structure</a:t>
-            </a:r>
-            <a:r>
-              <a:rPr lang="en-US" dirty="0" smtClean="0"/>
-              <a:t>.”</a:t>
-            </a:r>
-          </a:p>
-          <a:p>
-            <a:r>
-              <a:rPr lang="en-US" dirty="0"/>
-              <a:t>T</a:t>
-            </a:r>
-            <a:r>
-              <a:rPr lang="en-US" dirty="0" smtClean="0"/>
-              <a:t>he </a:t>
-            </a:r>
-            <a:r>
-              <a:rPr lang="en-US" dirty="0"/>
-              <a:t>Template Method Pattern allows you to define a common process (in this case, processing documents) while allowing subclasses to specify </a:t>
-            </a:r>
-            <a:r>
-              <a:rPr lang="en-US" dirty="0" smtClean="0"/>
-              <a:t>t</a:t>
-            </a:r>
-          </a:p>
-          <a:p>
-            <a:r>
-              <a:rPr lang="en-US" dirty="0"/>
-              <a:t>Summary</a:t>
-            </a:r>
-          </a:p>
-          <a:p>
-            <a:r>
-              <a:rPr lang="en-US" dirty="0"/>
-              <a:t> The Template Method Pattern allows you to define a common process (in this case, processing </a:t>
-            </a:r>
-          </a:p>
-          <a:p>
-            <a:r>
-              <a:rPr lang="en-US" dirty="0"/>
-              <a:t>documents) while allowing subclasses to specify the details of certain steps.</a:t>
-            </a:r>
-          </a:p>
-          <a:p>
-            <a:r>
-              <a:rPr lang="en-US" dirty="0"/>
-              <a:t> The </a:t>
-            </a:r>
-            <a:r>
-              <a:rPr lang="en-US" dirty="0" err="1"/>
-              <a:t>DocumentProcessor</a:t>
-            </a:r>
-            <a:r>
-              <a:rPr lang="en-US" dirty="0"/>
-              <a:t> class provides the structure for the algorithm, while </a:t>
-            </a:r>
-          </a:p>
-          <a:p>
-            <a:r>
-              <a:rPr lang="en-US" dirty="0" err="1"/>
-              <a:t>WordProcessor</a:t>
-            </a:r>
-            <a:r>
-              <a:rPr lang="en-US" dirty="0"/>
-              <a:t> and </a:t>
-            </a:r>
-            <a:r>
-              <a:rPr lang="en-US" dirty="0" err="1"/>
-              <a:t>PDFProcessor</a:t>
-            </a:r>
-            <a:r>
-              <a:rPr lang="en-US" dirty="0"/>
-              <a:t> provide their specific implementations. This promotes </a:t>
-            </a:r>
-          </a:p>
-          <a:p>
-            <a:r>
-              <a:rPr lang="en-US" dirty="0"/>
-              <a:t>code reuse and adherence to the DRY (Don't Repeat Yourself) principle.</a:t>
-            </a:r>
-          </a:p>
-          <a:p>
-            <a:r>
-              <a:rPr lang="en-US" dirty="0" smtClean="0"/>
-              <a:t>he </a:t>
-            </a:r>
-            <a:r>
-              <a:rPr lang="en-US" dirty="0"/>
-              <a:t>details of certain steps.</a:t>
-            </a:r>
-          </a:p>
-        </p:txBody>
-      </p:sp>
+        </p:nvPicPr>
+        <p:blipFill>
+          <a:blip r:embed="rId2"/>
+          <a:stretch>
+            <a:fillRect/>
+          </a:stretch>
+        </p:blipFill>
+        <p:spPr>
+          <a:xfrm>
+            <a:off x="1972235" y="1415578"/>
+            <a:ext cx="6302189" cy="4781630"/>
+          </a:xfrm>
+        </p:spPr>
+      </p:pic>
     </p:spTree>
     <p:extLst>
       <p:ext uri="{BB962C8B-B14F-4D97-AF65-F5344CB8AC3E}">
-        <p14:creationId xmlns:p14="http://schemas.microsoft.com/office/powerpoint/2010/main" val="1011303848"/>
+        <p14:creationId xmlns:p14="http://schemas.microsoft.com/office/powerpoint/2010/main" val="2514804209"/>
       </p:ext>
     </p:extLst>
   </p:cSld>
@@ -6487,7 +6479,13 @@
       </p:grpSpPr>
       <p:sp>
         <p:nvSpPr>
-          <p:cNvPr id="2" name="Title 1"/>
+          <p:cNvPr id="2" name="Title 1">
+            <a:extLst>
+              <a:ext uri="{FF2B5EF4-FFF2-40B4-BE49-F238E27FC236}">
+                <a16:creationId xmlns:a16="http://schemas.microsoft.com/office/drawing/2014/main" id="{26CEA8C1-A493-6E0B-0751-7F8E12C97074}"/>
+              </a:ext>
+            </a:extLst>
+          </p:cNvPr>
           <p:cNvSpPr>
             <a:spLocks noGrp="1"/>
           </p:cNvSpPr>
@@ -6501,19 +6499,21 @@
           <a:lstStyle/>
           <a:p>
             <a:r>
-              <a:rPr lang="en-US" dirty="0" smtClean="0"/>
-              <a:t>Observer Design Pattern</a:t>
-            </a:r>
-            <a:br>
-              <a:rPr lang="en-US" dirty="0" smtClean="0"/>
-            </a:br>
-            <a:endParaRPr lang="en-US" dirty="0"/>
-          </a:p>
-        </p:txBody>
-      </p:sp>
-      <p:sp>
-        <p:nvSpPr>
-          <p:cNvPr id="3" name="Content Placeholder 2"/>
+              <a:rPr lang="en-IN" dirty="0"/>
+              <a:t>Factory Design Pattern: Case Study</a:t>
+            </a:r>
+          </a:p>
+        </p:txBody>
+      </p:sp>
+      <p:sp>
+        <p:nvSpPr>
+          <p:cNvPr id="4" name="Content Placeholder 3">
+            <a:extLst>
+              <a:ext uri="{FF2B5EF4-FFF2-40B4-BE49-F238E27FC236}">
+                <a16:creationId xmlns:a16="http://schemas.microsoft.com/office/drawing/2014/main" id="{7AA2BCDE-431A-1364-5B66-B1BF6C8FE9E0}"/>
+              </a:ext>
+            </a:extLst>
+          </p:cNvPr>
           <p:cNvSpPr>
             <a:spLocks noGrp="1"/>
           </p:cNvSpPr>
@@ -6523,87 +6523,29 @@
         </p:nvSpPr>
         <p:spPr/>
         <p:txBody>
-          <a:bodyPr>
-            <a:normAutofit fontScale="92500" lnSpcReduction="20000"/>
-          </a:bodyPr>
-          <a:lstStyle/>
-          <a:p>
-            <a:r>
-              <a:rPr lang="en-US" dirty="0" smtClean="0"/>
-              <a:t>“The </a:t>
-            </a:r>
-            <a:r>
-              <a:rPr lang="en-US" dirty="0"/>
-              <a:t>Observer Design Pattern is useful when you want to create a subscription model where multiple objects (observers) are notified about changes in another object (subject</a:t>
-            </a:r>
-            <a:r>
-              <a:rPr lang="en-US" dirty="0" smtClean="0"/>
-              <a:t>).”</a:t>
-            </a:r>
-          </a:p>
-          <a:p>
-            <a:r>
-              <a:rPr lang="en-US" dirty="0" smtClean="0"/>
-              <a:t>Example: YouTube, E-com, Spotify, Netflix etc.. Notify the subscribers if any latest content available.</a:t>
-            </a:r>
-          </a:p>
-          <a:p>
-            <a:r>
-              <a:rPr lang="en-US" dirty="0" smtClean="0"/>
-              <a:t>Real-Time: </a:t>
-            </a:r>
-            <a:r>
-              <a:rPr lang="en-US" dirty="0" err="1" smtClean="0"/>
-              <a:t>WeatherStation</a:t>
-            </a:r>
-            <a:r>
-              <a:rPr lang="en-US" dirty="0" smtClean="0"/>
-              <a:t>, here we notify the temperature updates to all the subscribers</a:t>
-            </a:r>
-          </a:p>
-          <a:p>
-            <a:r>
-              <a:rPr lang="en-US" dirty="0"/>
-              <a:t>Summary</a:t>
-            </a:r>
-          </a:p>
-          <a:p>
-            <a:r>
-              <a:rPr lang="en-US" dirty="0"/>
-              <a:t>•	The Observer Design Pattern is useful when you want to create a subscription model where multiple objects (observers) are notified about changes in another object (subject).</a:t>
-            </a:r>
-          </a:p>
-          <a:p>
-            <a:r>
-              <a:rPr lang="en-US" dirty="0"/>
-              <a:t>•	In this implementation, the </a:t>
+          <a:bodyPr/>
+          <a:lstStyle/>
+          <a:p>
+            <a:r>
+              <a:rPr lang="en-US" dirty="0"/>
+              <a:t>Q. Design and implement </a:t>
             </a:r>
             <a:r>
               <a:rPr lang="en-US" dirty="0" err="1"/>
-              <a:t>WeatherStation</a:t>
-            </a:r>
-            <a:r>
-              <a:rPr lang="en-US" dirty="0"/>
-              <a:t> serves as the subject that tracks its state (temperature) and notifies all registered </a:t>
-            </a:r>
-            <a:r>
-              <a:rPr lang="en-US" dirty="0" err="1"/>
-              <a:t>DisplayDevice</a:t>
-            </a:r>
-            <a:r>
-              <a:rPr lang="en-US" dirty="0"/>
-              <a:t> instances whenever the temperature changes.</a:t>
-            </a:r>
-          </a:p>
-          <a:p>
-            <a:endParaRPr lang="en-US" dirty="0"/>
+              <a:t>ShapeFactory</a:t>
+            </a:r>
+            <a:r>
+              <a:rPr lang="en-US" dirty="0"/>
+              <a:t> class that generates different types of Shape objects (Circle, Square, Rectangle) based on input parameters using Factory Design Pattern. </a:t>
+            </a:r>
+            <a:endParaRPr lang="en-IN" dirty="0"/>
           </a:p>
         </p:txBody>
       </p:sp>
     </p:spTree>
     <p:extLst>
       <p:ext uri="{BB962C8B-B14F-4D97-AF65-F5344CB8AC3E}">
-        <p14:creationId xmlns:p14="http://schemas.microsoft.com/office/powerpoint/2010/main" val="2983634375"/>
+        <p14:creationId xmlns:p14="http://schemas.microsoft.com/office/powerpoint/2010/main" val="2101772648"/>
       </p:ext>
     </p:extLst>
   </p:cSld>
@@ -6632,7 +6574,13 @@
       </p:grpSpPr>
       <p:sp>
         <p:nvSpPr>
-          <p:cNvPr id="2" name="Title 1"/>
+          <p:cNvPr id="2" name="Title 1">
+            <a:extLst>
+              <a:ext uri="{FF2B5EF4-FFF2-40B4-BE49-F238E27FC236}">
+                <a16:creationId xmlns:a16="http://schemas.microsoft.com/office/drawing/2014/main" id="{FD823DFA-58F4-76E0-D4C2-A29C6C303AF6}"/>
+              </a:ext>
+            </a:extLst>
+          </p:cNvPr>
           <p:cNvSpPr>
             <a:spLocks noGrp="1"/>
           </p:cNvSpPr>
@@ -6646,16 +6594,21 @@
           <a:lstStyle/>
           <a:p>
             <a:r>
-              <a:rPr lang="en-US" dirty="0" smtClean="0"/>
-              <a:t>Proxy Design Pattern</a:t>
-            </a:r>
-            <a:endParaRPr lang="en-US" dirty="0"/>
-          </a:p>
-        </p:txBody>
-      </p:sp>
-      <p:sp>
-        <p:nvSpPr>
-          <p:cNvPr id="3" name="Content Placeholder 2"/>
+              <a:rPr lang="en-IN" dirty="0"/>
+              <a:t>Abstract Factory Design Pattern</a:t>
+            </a:r>
+          </a:p>
+        </p:txBody>
+      </p:sp>
+      <p:sp>
+        <p:nvSpPr>
+          <p:cNvPr id="3" name="Content Placeholder 2">
+            <a:extLst>
+              <a:ext uri="{FF2B5EF4-FFF2-40B4-BE49-F238E27FC236}">
+                <a16:creationId xmlns:a16="http://schemas.microsoft.com/office/drawing/2014/main" id="{C3D02A16-BB95-16D5-68A0-634A46A1BD7A}"/>
+              </a:ext>
+            </a:extLst>
+          </p:cNvPr>
           <p:cNvSpPr>
             <a:spLocks noGrp="1"/>
           </p:cNvSpPr>
@@ -6670,67 +6623,48 @@
           <a:p>
             <a:r>
               <a:rPr lang="en-US" dirty="0"/>
-              <a:t>The Proxy class controls access to the </a:t>
-            </a:r>
-            <a:r>
-              <a:rPr lang="en-US" dirty="0" err="1"/>
-              <a:t>RealResource</a:t>
-            </a:r>
-            <a:r>
-              <a:rPr lang="en-US" dirty="0"/>
-              <a:t> instance. It checks the user's permissions before allowing access to the </a:t>
-            </a:r>
-            <a:r>
-              <a:rPr lang="en-US" dirty="0" smtClean="0"/>
-              <a:t>resource.</a:t>
-            </a:r>
-          </a:p>
-          <a:p>
-            <a:r>
-              <a:rPr lang="en-US" dirty="0" smtClean="0"/>
-              <a:t>It act as gatekeeper</a:t>
-            </a:r>
-          </a:p>
-          <a:p>
-            <a:r>
-              <a:rPr lang="en-US" dirty="0" smtClean="0"/>
-              <a:t>Ex: Unwanted  Cisco Network packet entry in organization</a:t>
-            </a:r>
-          </a:p>
-          <a:p>
-            <a:r>
-              <a:rPr lang="en-US" dirty="0"/>
-              <a:t>Summary </a:t>
-            </a:r>
-            <a:r>
-              <a:rPr lang="en-US" dirty="0" smtClean="0"/>
-              <a:t>:</a:t>
-            </a:r>
-          </a:p>
-          <a:p>
-            <a:r>
-              <a:rPr lang="en-US" dirty="0" smtClean="0"/>
-              <a:t> </a:t>
-            </a:r>
-            <a:r>
-              <a:rPr lang="en-US" dirty="0"/>
-              <a:t>The Proxy Design Pattern is useful when you want to provide a surrogate or placeholder for another object to control access to it.  In this implementation, the Proxy checks the user's permissions before allowing access to the </a:t>
-            </a:r>
-            <a:r>
-              <a:rPr lang="en-US" dirty="0" err="1"/>
-              <a:t>RealResource</a:t>
-            </a:r>
-            <a:r>
-              <a:rPr lang="en-US" dirty="0"/>
-              <a:t>, effectively acting as a gatekeeper.</a:t>
-            </a:r>
-          </a:p>
-        </p:txBody>
-      </p:sp>
+              <a:t>The Abstract Factory Pattern, which allows the creation of families of related or dependent objects (in this case, shoes and clothes) without specifying their concrete classes.</a:t>
+            </a:r>
+          </a:p>
+          <a:p>
+            <a:endParaRPr lang="en-IN" dirty="0"/>
+          </a:p>
+        </p:txBody>
+      </p:sp>
+      <p:pic>
+        <p:nvPicPr>
+          <p:cNvPr id="5" name="Picture 4">
+            <a:extLst>
+              <a:ext uri="{FF2B5EF4-FFF2-40B4-BE49-F238E27FC236}">
+                <a16:creationId xmlns:a16="http://schemas.microsoft.com/office/drawing/2014/main" id="{E7AC0074-7FBD-EFB1-1088-AED439D08542}"/>
+              </a:ext>
+            </a:extLst>
+          </p:cNvPr>
+          <p:cNvPicPr>
+            <a:picLocks noChangeAspect="1"/>
+          </p:cNvPicPr>
+          <p:nvPr/>
+        </p:nvPicPr>
+        <p:blipFill>
+          <a:blip r:embed="rId2"/>
+          <a:stretch>
+            <a:fillRect/>
+          </a:stretch>
+        </p:blipFill>
+        <p:spPr>
+          <a:xfrm>
+            <a:off x="2211082" y="3191434"/>
+            <a:ext cx="6731000" cy="3361765"/>
+          </a:xfrm>
+          <a:prstGeom prst="rect">
+            <a:avLst/>
+          </a:prstGeom>
+        </p:spPr>
+      </p:pic>
     </p:spTree>
     <p:extLst>
       <p:ext uri="{BB962C8B-B14F-4D97-AF65-F5344CB8AC3E}">
-        <p14:creationId xmlns:p14="http://schemas.microsoft.com/office/powerpoint/2010/main" val="4151292056"/>
+        <p14:creationId xmlns:p14="http://schemas.microsoft.com/office/powerpoint/2010/main" val="4249870996"/>
       </p:ext>
     </p:extLst>
   </p:cSld>
@@ -6759,7 +6693,13 @@
       </p:grpSpPr>
       <p:sp>
         <p:nvSpPr>
-          <p:cNvPr id="2" name="Title 1"/>
+          <p:cNvPr id="2" name="Title 1">
+            <a:extLst>
+              <a:ext uri="{FF2B5EF4-FFF2-40B4-BE49-F238E27FC236}">
+                <a16:creationId xmlns:a16="http://schemas.microsoft.com/office/drawing/2014/main" id="{FD823DFA-58F4-76E0-D4C2-A29C6C303AF6}"/>
+              </a:ext>
+            </a:extLst>
+          </p:cNvPr>
           <p:cNvSpPr>
             <a:spLocks noGrp="1"/>
           </p:cNvSpPr>
@@ -6773,16 +6713,21 @@
           <a:lstStyle/>
           <a:p>
             <a:r>
-              <a:rPr lang="en-US" dirty="0" smtClean="0"/>
-              <a:t>Mediator Pattern</a:t>
-            </a:r>
-            <a:endParaRPr lang="en-US" dirty="0"/>
-          </a:p>
-        </p:txBody>
-      </p:sp>
-      <p:sp>
-        <p:nvSpPr>
-          <p:cNvPr id="3" name="Content Placeholder 2"/>
+              <a:rPr lang="en-IN" dirty="0"/>
+              <a:t>Abstract Factory Design Pattern</a:t>
+            </a:r>
+          </a:p>
+        </p:txBody>
+      </p:sp>
+      <p:sp>
+        <p:nvSpPr>
+          <p:cNvPr id="3" name="Content Placeholder 2">
+            <a:extLst>
+              <a:ext uri="{FF2B5EF4-FFF2-40B4-BE49-F238E27FC236}">
+                <a16:creationId xmlns:a16="http://schemas.microsoft.com/office/drawing/2014/main" id="{C3D02A16-BB95-16D5-68A0-634A46A1BD7A}"/>
+              </a:ext>
+            </a:extLst>
+          </p:cNvPr>
           <p:cNvSpPr>
             <a:spLocks noGrp="1"/>
           </p:cNvSpPr>
@@ -6797,72 +6742,48 @@
           <a:p>
             <a:r>
               <a:rPr lang="en-US" dirty="0"/>
-              <a:t>The </a:t>
-            </a:r>
-            <a:r>
-              <a:rPr lang="en-US" b="1" dirty="0"/>
-              <a:t>Mediator Design Pattern</a:t>
-            </a:r>
-            <a:r>
-              <a:rPr lang="en-US" dirty="0"/>
-              <a:t> belongs to the </a:t>
-            </a:r>
-            <a:r>
-              <a:rPr lang="en-US" b="1" dirty="0"/>
-              <a:t>Behavioral Design Patterns</a:t>
-            </a:r>
-            <a:r>
-              <a:rPr lang="en-US" dirty="0"/>
-              <a:t> category</a:t>
-            </a:r>
-            <a:r>
-              <a:rPr lang="en-US" dirty="0" smtClean="0"/>
-              <a:t>.</a:t>
-            </a:r>
-          </a:p>
-          <a:p>
-            <a:r>
-              <a:rPr lang="en-US" dirty="0" smtClean="0"/>
-              <a:t>Definition: “The </a:t>
-            </a:r>
-            <a:r>
-              <a:rPr lang="en-US" dirty="0"/>
-              <a:t>Mediator pattern defines an object (mediator) that encapsulates how a set of objects interact with each other, reducing direct dependencies between </a:t>
-            </a:r>
-            <a:r>
-              <a:rPr lang="en-US" dirty="0" smtClean="0"/>
-              <a:t>them.”</a:t>
-            </a:r>
-          </a:p>
-          <a:p>
-            <a:r>
-              <a:rPr lang="en-US" b="1" dirty="0"/>
-              <a:t>Real-World Example:</a:t>
-            </a:r>
-          </a:p>
-          <a:p>
-            <a:r>
-              <a:rPr lang="en-US" dirty="0"/>
-              <a:t>In a chat application, participants (users) do not communicate directly with each other. Instead, a "</a:t>
-            </a:r>
-            <a:r>
-              <a:rPr lang="en-US" dirty="0" err="1"/>
-              <a:t>ChatRoom</a:t>
-            </a:r>
-            <a:r>
-              <a:rPr lang="en-US" dirty="0"/>
-              <a:t>" (mediator) facilitates communication between users. This way, users are not aware of the other participants' details, and the chat room controls the message flow.</a:t>
-            </a:r>
-          </a:p>
-          <a:p>
-            <a:endParaRPr lang="en-US" dirty="0"/>
-          </a:p>
-        </p:txBody>
-      </p:sp>
+              <a:t>The Abstract Factory Pattern, which allows the creation of families of related or dependent objects (in this case, shoes and clothes) without specifying their concrete classes.</a:t>
+            </a:r>
+          </a:p>
+          <a:p>
+            <a:endParaRPr lang="en-IN" dirty="0"/>
+          </a:p>
+        </p:txBody>
+      </p:sp>
+      <p:pic>
+        <p:nvPicPr>
+          <p:cNvPr id="8" name="Picture 7">
+            <a:extLst>
+              <a:ext uri="{FF2B5EF4-FFF2-40B4-BE49-F238E27FC236}">
+                <a16:creationId xmlns:a16="http://schemas.microsoft.com/office/drawing/2014/main" id="{BA9FE848-38FF-DA25-7EA9-7CECCAF1CF3D}"/>
+              </a:ext>
+            </a:extLst>
+          </p:cNvPr>
+          <p:cNvPicPr>
+            <a:picLocks noChangeAspect="1"/>
+          </p:cNvPicPr>
+          <p:nvPr/>
+        </p:nvPicPr>
+        <p:blipFill>
+          <a:blip r:embed="rId2"/>
+          <a:stretch>
+            <a:fillRect/>
+          </a:stretch>
+        </p:blipFill>
+        <p:spPr>
+          <a:xfrm>
+            <a:off x="2272256" y="3429000"/>
+            <a:ext cx="6152432" cy="3074893"/>
+          </a:xfrm>
+          <a:prstGeom prst="rect">
+            <a:avLst/>
+          </a:prstGeom>
+        </p:spPr>
+      </p:pic>
     </p:spTree>
     <p:extLst>
       <p:ext uri="{BB962C8B-B14F-4D97-AF65-F5344CB8AC3E}">
-        <p14:creationId xmlns:p14="http://schemas.microsoft.com/office/powerpoint/2010/main" val="959658077"/>
+        <p14:creationId xmlns:p14="http://schemas.microsoft.com/office/powerpoint/2010/main" val="865979175"/>
       </p:ext>
     </p:extLst>
   </p:cSld>
@@ -6891,7 +6812,13 @@
       </p:grpSpPr>
       <p:sp>
         <p:nvSpPr>
-          <p:cNvPr id="2" name="Title 1"/>
+          <p:cNvPr id="2" name="Title 1">
+            <a:extLst>
+              <a:ext uri="{FF2B5EF4-FFF2-40B4-BE49-F238E27FC236}">
+                <a16:creationId xmlns:a16="http://schemas.microsoft.com/office/drawing/2014/main" id="{AF00E5D0-E7BA-F944-FD84-BA69CC14BFD5}"/>
+              </a:ext>
+            </a:extLst>
+          </p:cNvPr>
           <p:cNvSpPr>
             <a:spLocks noGrp="1"/>
           </p:cNvSpPr>
@@ -6905,16 +6832,21 @@
           <a:lstStyle/>
           <a:p>
             <a:r>
-              <a:rPr lang="en-US" dirty="0" smtClean="0"/>
-              <a:t>Mediator Pattern</a:t>
-            </a:r>
-            <a:endParaRPr lang="en-US" dirty="0"/>
-          </a:p>
-        </p:txBody>
-      </p:sp>
-      <p:sp>
-        <p:nvSpPr>
-          <p:cNvPr id="3" name="Content Placeholder 2"/>
+              <a:rPr lang="en-IN" dirty="0"/>
+              <a:t>Builder Design Pattern</a:t>
+            </a:r>
+          </a:p>
+        </p:txBody>
+      </p:sp>
+      <p:sp>
+        <p:nvSpPr>
+          <p:cNvPr id="3" name="Content Placeholder 2">
+            <a:extLst>
+              <a:ext uri="{FF2B5EF4-FFF2-40B4-BE49-F238E27FC236}">
+                <a16:creationId xmlns:a16="http://schemas.microsoft.com/office/drawing/2014/main" id="{9A1FD7FC-D230-A9B3-8EC2-FF11C3CAED3B}"/>
+              </a:ext>
+            </a:extLst>
+          </p:cNvPr>
           <p:cNvSpPr>
             <a:spLocks noGrp="1"/>
           </p:cNvSpPr>
@@ -6924,68 +6856,331 @@
         </p:nvSpPr>
         <p:spPr/>
         <p:txBody>
-          <a:bodyPr>
-            <a:normAutofit lnSpcReduction="10000"/>
-          </a:bodyPr>
-          <a:lstStyle/>
-          <a:p>
-            <a:r>
-              <a:rPr lang="en-US" dirty="0"/>
-              <a:t>Q. Design and Implement a Mediator pattern to manage communication between a set of objects (e.g., chat room with multiple participants</a:t>
-            </a:r>
-            <a:r>
-              <a:rPr lang="en-US" dirty="0" smtClean="0"/>
-              <a:t>).?</a:t>
-            </a:r>
-          </a:p>
-          <a:p>
-            <a:endParaRPr lang="en-US" dirty="0"/>
-          </a:p>
-          <a:p>
-            <a:r>
-              <a:rPr lang="en-US" dirty="0"/>
-              <a:t>Summary </a:t>
-            </a:r>
-            <a:r>
-              <a:rPr lang="en-US" dirty="0" smtClean="0"/>
-              <a:t>:</a:t>
-            </a:r>
-          </a:p>
-          <a:p>
-            <a:r>
-              <a:rPr lang="en-US" dirty="0" smtClean="0"/>
-              <a:t> </a:t>
-            </a:r>
-            <a:r>
-              <a:rPr lang="en-US" dirty="0"/>
-              <a:t>The Mediator Design Pattern allows for the decoupling of components by using a mediator to facilitate communication between them. </a:t>
-            </a:r>
-            <a:endParaRPr lang="en-US" dirty="0" smtClean="0"/>
-          </a:p>
-          <a:p>
-            <a:r>
-              <a:rPr lang="en-US" dirty="0" smtClean="0"/>
-              <a:t>In </a:t>
-            </a:r>
-            <a:r>
-              <a:rPr lang="en-US" dirty="0"/>
-              <a:t>this example, the </a:t>
-            </a:r>
-            <a:r>
-              <a:rPr lang="en-US" dirty="0" err="1"/>
-              <a:t>ChatRoom</a:t>
-            </a:r>
-            <a:r>
-              <a:rPr lang="en-US" dirty="0"/>
-              <a:t> class serves as the mediator that manages the interaction between Participant instances, making the system more organized and reducing dependencies among the components.</a:t>
-            </a:r>
-          </a:p>
-        </p:txBody>
-      </p:sp>
+          <a:bodyPr/>
+          <a:lstStyle/>
+          <a:p>
+            <a:r>
+              <a:rPr lang="en-IN" dirty="0"/>
+              <a:t>The Builder Design Pattern is </a:t>
+            </a:r>
+            <a:r>
+              <a:rPr lang="en-US" b="0" i="0" dirty="0">
+                <a:solidFill>
+                  <a:srgbClr val="FFFFFF"/>
+                </a:solidFill>
+                <a:effectLst/>
+                <a:latin typeface="Google Sans"/>
+              </a:rPr>
+              <a:t>a creational design pattern that is used to construct a complex object </a:t>
+            </a:r>
+            <a:r>
+              <a:rPr lang="en-US" b="0" i="0" dirty="0">
+                <a:solidFill>
+                  <a:srgbClr val="EEF0FF"/>
+                </a:solidFill>
+                <a:effectLst/>
+                <a:latin typeface="Google Sans"/>
+              </a:rPr>
+              <a:t>in a flexible and step-by-step manner</a:t>
+            </a:r>
+            <a:r>
+              <a:rPr lang="en-US" b="0" i="0" dirty="0">
+                <a:solidFill>
+                  <a:srgbClr val="E8E8E8"/>
+                </a:solidFill>
+                <a:effectLst/>
+                <a:latin typeface="Google Sans"/>
+              </a:rPr>
+              <a:t>.</a:t>
+            </a:r>
+            <a:endParaRPr lang="en-IN" dirty="0"/>
+          </a:p>
+        </p:txBody>
+      </p:sp>
+      <p:pic>
+        <p:nvPicPr>
+          <p:cNvPr id="5" name="Picture 4">
+            <a:extLst>
+              <a:ext uri="{FF2B5EF4-FFF2-40B4-BE49-F238E27FC236}">
+                <a16:creationId xmlns:a16="http://schemas.microsoft.com/office/drawing/2014/main" id="{C8C5EE60-2C79-BBEF-686A-678A2E89A769}"/>
+              </a:ext>
+            </a:extLst>
+          </p:cNvPr>
+          <p:cNvPicPr>
+            <a:picLocks noChangeAspect="1"/>
+          </p:cNvPicPr>
+          <p:nvPr/>
+        </p:nvPicPr>
+        <p:blipFill>
+          <a:blip r:embed="rId2"/>
+          <a:stretch>
+            <a:fillRect/>
+          </a:stretch>
+        </p:blipFill>
+        <p:spPr>
+          <a:xfrm>
+            <a:off x="2142147" y="3146612"/>
+            <a:ext cx="6096000" cy="3442447"/>
+          </a:xfrm>
+          <a:prstGeom prst="rect">
+            <a:avLst/>
+          </a:prstGeom>
+        </p:spPr>
+      </p:pic>
     </p:spTree>
     <p:extLst>
       <p:ext uri="{BB962C8B-B14F-4D97-AF65-F5344CB8AC3E}">
-        <p14:creationId xmlns:p14="http://schemas.microsoft.com/office/powerpoint/2010/main" val="3579317689"/>
+        <p14:creationId xmlns:p14="http://schemas.microsoft.com/office/powerpoint/2010/main" val="2917559437"/>
+      </p:ext>
+    </p:extLst>
+  </p:cSld>
+  <p:clrMapOvr>
+    <a:masterClrMapping/>
+  </p:clrMapOvr>
+</p:sld>
+</file>
+
+<file path=ppt/slides/slide18.xml><?xml version="1.0" encoding="utf-8"?>
+<p:sld xmlns:a="http://schemas.openxmlformats.org/drawingml/2006/main" xmlns:r="http://schemas.openxmlformats.org/officeDocument/2006/relationships" xmlns:p="http://schemas.openxmlformats.org/presentationml/2006/main">
+  <p:cSld>
+    <p:spTree>
+      <p:nvGrpSpPr>
+        <p:cNvPr id="1" name=""/>
+        <p:cNvGrpSpPr/>
+        <p:nvPr/>
+      </p:nvGrpSpPr>
+      <p:grpSpPr>
+        <a:xfrm>
+          <a:off x="0" y="0"/>
+          <a:ext cx="0" cy="0"/>
+          <a:chOff x="0" y="0"/>
+          <a:chExt cx="0" cy="0"/>
+        </a:xfrm>
+      </p:grpSpPr>
+      <p:sp>
+        <p:nvSpPr>
+          <p:cNvPr id="2" name="Title 1">
+            <a:extLst>
+              <a:ext uri="{FF2B5EF4-FFF2-40B4-BE49-F238E27FC236}">
+                <a16:creationId xmlns:a16="http://schemas.microsoft.com/office/drawing/2014/main" id="{625E771A-B257-764B-CD5C-E7C367F3027B}"/>
+              </a:ext>
+            </a:extLst>
+          </p:cNvPr>
+          <p:cNvSpPr>
+            <a:spLocks noGrp="1"/>
+          </p:cNvSpPr>
+          <p:nvPr>
+            <p:ph type="title"/>
+          </p:nvPr>
+        </p:nvSpPr>
+        <p:spPr/>
+        <p:txBody>
+          <a:bodyPr/>
+          <a:lstStyle/>
+          <a:p>
+            <a:r>
+              <a:rPr lang="en-IN" dirty="0"/>
+              <a:t>Builder Design Pattern</a:t>
+            </a:r>
+            <a:br>
+              <a:rPr lang="en-IN" dirty="0"/>
+            </a:br>
+            <a:endParaRPr lang="en-IN" dirty="0"/>
+          </a:p>
+        </p:txBody>
+      </p:sp>
+      <p:pic>
+        <p:nvPicPr>
+          <p:cNvPr id="5" name="Content Placeholder 4">
+            <a:extLst>
+              <a:ext uri="{FF2B5EF4-FFF2-40B4-BE49-F238E27FC236}">
+                <a16:creationId xmlns:a16="http://schemas.microsoft.com/office/drawing/2014/main" id="{608E0514-A17E-6AC4-0D6C-F00947D793C9}"/>
+              </a:ext>
+            </a:extLst>
+          </p:cNvPr>
+          <p:cNvPicPr>
+            <a:picLocks noGrp="1" noChangeAspect="1"/>
+          </p:cNvPicPr>
+          <p:nvPr>
+            <p:ph idx="1"/>
+          </p:nvPr>
+        </p:nvPicPr>
+        <p:blipFill>
+          <a:blip r:embed="rId2"/>
+          <a:stretch>
+            <a:fillRect/>
+          </a:stretch>
+        </p:blipFill>
+        <p:spPr>
+          <a:xfrm>
+            <a:off x="173412" y="2134021"/>
+            <a:ext cx="5715000" cy="3333750"/>
+          </a:xfrm>
+        </p:spPr>
+      </p:pic>
+      <p:pic>
+        <p:nvPicPr>
+          <p:cNvPr id="7" name="Picture 6">
+            <a:extLst>
+              <a:ext uri="{FF2B5EF4-FFF2-40B4-BE49-F238E27FC236}">
+                <a16:creationId xmlns:a16="http://schemas.microsoft.com/office/drawing/2014/main" id="{A3789D65-F0F7-1C7B-FE1B-53DD57E69F06}"/>
+              </a:ext>
+            </a:extLst>
+          </p:cNvPr>
+          <p:cNvPicPr>
+            <a:picLocks noChangeAspect="1"/>
+          </p:cNvPicPr>
+          <p:nvPr/>
+        </p:nvPicPr>
+        <p:blipFill>
+          <a:blip r:embed="rId3"/>
+          <a:stretch>
+            <a:fillRect/>
+          </a:stretch>
+        </p:blipFill>
+        <p:spPr>
+          <a:xfrm>
+            <a:off x="6221757" y="2554941"/>
+            <a:ext cx="5081990" cy="2628153"/>
+          </a:xfrm>
+          <a:prstGeom prst="rect">
+            <a:avLst/>
+          </a:prstGeom>
+        </p:spPr>
+      </p:pic>
+      <p:sp>
+        <p:nvSpPr>
+          <p:cNvPr id="9" name="TextBox 8">
+            <a:extLst>
+              <a:ext uri="{FF2B5EF4-FFF2-40B4-BE49-F238E27FC236}">
+                <a16:creationId xmlns:a16="http://schemas.microsoft.com/office/drawing/2014/main" id="{500F8C7C-2E53-ECA7-AC1B-BCBAD647202E}"/>
+              </a:ext>
+            </a:extLst>
+          </p:cNvPr>
+          <p:cNvSpPr txBox="1"/>
+          <p:nvPr/>
+        </p:nvSpPr>
+        <p:spPr>
+          <a:xfrm>
+            <a:off x="573741" y="1129553"/>
+            <a:ext cx="10524565" cy="923330"/>
+          </a:xfrm>
+          <a:prstGeom prst="rect">
+            <a:avLst/>
+          </a:prstGeom>
+          <a:noFill/>
+        </p:spPr>
+        <p:txBody>
+          <a:bodyPr wrap="square">
+            <a:spAutoFit/>
+          </a:bodyPr>
+          <a:lstStyle/>
+          <a:p>
+            <a:r>
+              <a:rPr lang="en-US" dirty="0"/>
+              <a:t>the Builder Pattern allows for the creation of different representations of a complex object (House) by using specific builders.  The use of the Director class simplifies the process of constructing the object, encapsulating the construction logic away from the client code.</a:t>
+            </a:r>
+            <a:endParaRPr lang="en-IN" dirty="0"/>
+          </a:p>
+        </p:txBody>
+      </p:sp>
+    </p:spTree>
+    <p:extLst>
+      <p:ext uri="{BB962C8B-B14F-4D97-AF65-F5344CB8AC3E}">
+        <p14:creationId xmlns:p14="http://schemas.microsoft.com/office/powerpoint/2010/main" val="1284593591"/>
+      </p:ext>
+    </p:extLst>
+  </p:cSld>
+  <p:clrMapOvr>
+    <a:masterClrMapping/>
+  </p:clrMapOvr>
+</p:sld>
+</file>
+
+<file path=ppt/slides/slide19.xml><?xml version="1.0" encoding="utf-8"?>
+<p:sld xmlns:a="http://schemas.openxmlformats.org/drawingml/2006/main" xmlns:r="http://schemas.openxmlformats.org/officeDocument/2006/relationships" xmlns:p="http://schemas.openxmlformats.org/presentationml/2006/main">
+  <p:cSld>
+    <p:spTree>
+      <p:nvGrpSpPr>
+        <p:cNvPr id="1" name=""/>
+        <p:cNvGrpSpPr/>
+        <p:nvPr/>
+      </p:nvGrpSpPr>
+      <p:grpSpPr>
+        <a:xfrm>
+          <a:off x="0" y="0"/>
+          <a:ext cx="0" cy="0"/>
+          <a:chOff x="0" y="0"/>
+          <a:chExt cx="0" cy="0"/>
+        </a:xfrm>
+      </p:grpSpPr>
+      <p:sp>
+        <p:nvSpPr>
+          <p:cNvPr id="2" name="Title 1">
+            <a:extLst>
+              <a:ext uri="{FF2B5EF4-FFF2-40B4-BE49-F238E27FC236}">
+                <a16:creationId xmlns:a16="http://schemas.microsoft.com/office/drawing/2014/main" id="{62E8AF3A-06EA-7CA5-64A5-428A9C0ECB8C}"/>
+              </a:ext>
+            </a:extLst>
+          </p:cNvPr>
+          <p:cNvSpPr>
+            <a:spLocks noGrp="1"/>
+          </p:cNvSpPr>
+          <p:nvPr>
+            <p:ph type="title"/>
+          </p:nvPr>
+        </p:nvSpPr>
+        <p:spPr/>
+        <p:txBody>
+          <a:bodyPr/>
+          <a:lstStyle/>
+          <a:p>
+            <a:r>
+              <a:rPr lang="en-IN" dirty="0"/>
+              <a:t>Decorator Design Pattern</a:t>
+            </a:r>
+          </a:p>
+        </p:txBody>
+      </p:sp>
+      <p:sp>
+        <p:nvSpPr>
+          <p:cNvPr id="3" name="Content Placeholder 2">
+            <a:extLst>
+              <a:ext uri="{FF2B5EF4-FFF2-40B4-BE49-F238E27FC236}">
+                <a16:creationId xmlns:a16="http://schemas.microsoft.com/office/drawing/2014/main" id="{9C373F8D-D55C-809D-AFA1-5B06EE37262E}"/>
+              </a:ext>
+            </a:extLst>
+          </p:cNvPr>
+          <p:cNvSpPr>
+            <a:spLocks noGrp="1"/>
+          </p:cNvSpPr>
+          <p:nvPr>
+            <p:ph idx="1"/>
+          </p:nvPr>
+        </p:nvSpPr>
+        <p:spPr/>
+        <p:txBody>
+          <a:bodyPr/>
+          <a:lstStyle/>
+          <a:p>
+            <a:r>
+              <a:rPr lang="en-US" dirty="0"/>
+              <a:t>the Decorator Pattern allows for the dynamic addition of functionalities to an object without modifying its structure.</a:t>
+            </a:r>
+          </a:p>
+          <a:p>
+            <a:r>
+              <a:rPr lang="en-US" dirty="0"/>
+              <a:t>the Decorator Pattern allows for the dynamic addition of functionalities (in this case, additional ingredients) to an object (coffee) without modifying its structure.</a:t>
+            </a:r>
+            <a:endParaRPr lang="en-IN" dirty="0"/>
+          </a:p>
+        </p:txBody>
+      </p:sp>
+    </p:spTree>
+    <p:extLst>
+      <p:ext uri="{BB962C8B-B14F-4D97-AF65-F5344CB8AC3E}">
+        <p14:creationId xmlns:p14="http://schemas.microsoft.com/office/powerpoint/2010/main" val="2042257217"/>
       </p:ext>
     </p:extLst>
   </p:cSld>
@@ -7028,10 +7223,9 @@
           <a:lstStyle/>
           <a:p>
             <a:r>
-              <a:rPr lang="en-US" dirty="0" smtClean="0"/>
+              <a:rPr lang="en-US" dirty="0"/>
               <a:t>What is Design Pattern?</a:t>
             </a:r>
-            <a:endParaRPr lang="en-US" dirty="0"/>
           </a:p>
         </p:txBody>
       </p:sp>
@@ -7052,11 +7246,7 @@
           <a:p>
             <a:r>
               <a:rPr lang="en-US" dirty="0"/>
-              <a:t>Design patterns are standard solutions to common problems in software design. They provide a template or blueprint that developers can follow to address recurring design challenges, promoting best practices and improving code maintainability, flexibility, and scalability</a:t>
-            </a:r>
-            <a:r>
-              <a:rPr lang="en-US" dirty="0" smtClean="0"/>
-              <a:t>.</a:t>
+              <a:t>Design patterns are standard solutions to common problems in software design. They provide a template or blueprint that developers can follow to address recurring design challenges, promoting best practices and improving code maintainability, flexibility, and scalability.</a:t>
             </a:r>
           </a:p>
           <a:p>
@@ -7071,6 +7261,1149 @@
     <p:extLst>
       <p:ext uri="{BB962C8B-B14F-4D97-AF65-F5344CB8AC3E}">
         <p14:creationId xmlns:p14="http://schemas.microsoft.com/office/powerpoint/2010/main" val="1143219444"/>
+      </p:ext>
+    </p:extLst>
+  </p:cSld>
+  <p:clrMapOvr>
+    <a:masterClrMapping/>
+  </p:clrMapOvr>
+</p:sld>
+</file>
+
+<file path=ppt/slides/slide20.xml><?xml version="1.0" encoding="utf-8"?>
+<p:sld xmlns:a="http://schemas.openxmlformats.org/drawingml/2006/main" xmlns:r="http://schemas.openxmlformats.org/officeDocument/2006/relationships" xmlns:p="http://schemas.openxmlformats.org/presentationml/2006/main">
+  <p:cSld>
+    <p:spTree>
+      <p:nvGrpSpPr>
+        <p:cNvPr id="1" name=""/>
+        <p:cNvGrpSpPr/>
+        <p:nvPr/>
+      </p:nvGrpSpPr>
+      <p:grpSpPr>
+        <a:xfrm>
+          <a:off x="0" y="0"/>
+          <a:ext cx="0" cy="0"/>
+          <a:chOff x="0" y="0"/>
+          <a:chExt cx="0" cy="0"/>
+        </a:xfrm>
+      </p:grpSpPr>
+      <p:sp>
+        <p:nvSpPr>
+          <p:cNvPr id="2" name="Title 1">
+            <a:extLst>
+              <a:ext uri="{FF2B5EF4-FFF2-40B4-BE49-F238E27FC236}">
+                <a16:creationId xmlns:a16="http://schemas.microsoft.com/office/drawing/2014/main" id="{DB1BF403-01DD-7789-F58C-422E238F4D18}"/>
+              </a:ext>
+            </a:extLst>
+          </p:cNvPr>
+          <p:cNvSpPr>
+            <a:spLocks noGrp="1"/>
+          </p:cNvSpPr>
+          <p:nvPr>
+            <p:ph type="title"/>
+          </p:nvPr>
+        </p:nvSpPr>
+        <p:spPr/>
+        <p:txBody>
+          <a:bodyPr/>
+          <a:lstStyle/>
+          <a:p>
+            <a:r>
+              <a:rPr lang="en-IN" dirty="0"/>
+              <a:t>Decorator Design Pattern</a:t>
+            </a:r>
+          </a:p>
+        </p:txBody>
+      </p:sp>
+      <p:pic>
+        <p:nvPicPr>
+          <p:cNvPr id="5" name="Content Placeholder 4">
+            <a:extLst>
+              <a:ext uri="{FF2B5EF4-FFF2-40B4-BE49-F238E27FC236}">
+                <a16:creationId xmlns:a16="http://schemas.microsoft.com/office/drawing/2014/main" id="{C45FA12C-95B3-F9D3-2400-6C02D4A03576}"/>
+              </a:ext>
+            </a:extLst>
+          </p:cNvPr>
+          <p:cNvPicPr>
+            <a:picLocks noGrp="1" noChangeAspect="1"/>
+          </p:cNvPicPr>
+          <p:nvPr>
+            <p:ph idx="1"/>
+          </p:nvPr>
+        </p:nvPicPr>
+        <p:blipFill>
+          <a:blip r:embed="rId2"/>
+          <a:stretch>
+            <a:fillRect/>
+          </a:stretch>
+        </p:blipFill>
+        <p:spPr>
+          <a:xfrm>
+            <a:off x="2922493" y="1354707"/>
+            <a:ext cx="5773271" cy="5207458"/>
+          </a:xfrm>
+        </p:spPr>
+      </p:pic>
+    </p:spTree>
+    <p:extLst>
+      <p:ext uri="{BB962C8B-B14F-4D97-AF65-F5344CB8AC3E}">
+        <p14:creationId xmlns:p14="http://schemas.microsoft.com/office/powerpoint/2010/main" val="3116234053"/>
+      </p:ext>
+    </p:extLst>
+  </p:cSld>
+  <p:clrMapOvr>
+    <a:masterClrMapping/>
+  </p:clrMapOvr>
+</p:sld>
+</file>
+
+<file path=ppt/slides/slide21.xml><?xml version="1.0" encoding="utf-8"?>
+<p:sld xmlns:a="http://schemas.openxmlformats.org/drawingml/2006/main" xmlns:r="http://schemas.openxmlformats.org/officeDocument/2006/relationships" xmlns:p="http://schemas.openxmlformats.org/presentationml/2006/main">
+  <p:cSld>
+    <p:spTree>
+      <p:nvGrpSpPr>
+        <p:cNvPr id="1" name=""/>
+        <p:cNvGrpSpPr/>
+        <p:nvPr/>
+      </p:nvGrpSpPr>
+      <p:grpSpPr>
+        <a:xfrm>
+          <a:off x="0" y="0"/>
+          <a:ext cx="0" cy="0"/>
+          <a:chOff x="0" y="0"/>
+          <a:chExt cx="0" cy="0"/>
+        </a:xfrm>
+      </p:grpSpPr>
+      <p:sp>
+        <p:nvSpPr>
+          <p:cNvPr id="2" name="Title 1">
+            <a:extLst>
+              <a:ext uri="{FF2B5EF4-FFF2-40B4-BE49-F238E27FC236}">
+                <a16:creationId xmlns:a16="http://schemas.microsoft.com/office/drawing/2014/main" id="{DB1BF403-01DD-7789-F58C-422E238F4D18}"/>
+              </a:ext>
+            </a:extLst>
+          </p:cNvPr>
+          <p:cNvSpPr>
+            <a:spLocks noGrp="1"/>
+          </p:cNvSpPr>
+          <p:nvPr>
+            <p:ph type="title"/>
+          </p:nvPr>
+        </p:nvSpPr>
+        <p:spPr/>
+        <p:txBody>
+          <a:bodyPr/>
+          <a:lstStyle/>
+          <a:p>
+            <a:r>
+              <a:rPr lang="en-IN" dirty="0"/>
+              <a:t>Decorator Design Pattern</a:t>
+            </a:r>
+          </a:p>
+        </p:txBody>
+      </p:sp>
+      <p:pic>
+        <p:nvPicPr>
+          <p:cNvPr id="7" name="Content Placeholder 6">
+            <a:extLst>
+              <a:ext uri="{FF2B5EF4-FFF2-40B4-BE49-F238E27FC236}">
+                <a16:creationId xmlns:a16="http://schemas.microsoft.com/office/drawing/2014/main" id="{5786CBAD-7097-AB88-61B4-E1B53449F5A3}"/>
+              </a:ext>
+            </a:extLst>
+          </p:cNvPr>
+          <p:cNvPicPr>
+            <a:picLocks noGrp="1" noChangeAspect="1"/>
+          </p:cNvPicPr>
+          <p:nvPr>
+            <p:ph idx="1"/>
+          </p:nvPr>
+        </p:nvPicPr>
+        <p:blipFill>
+          <a:blip r:embed="rId2"/>
+          <a:stretch>
+            <a:fillRect/>
+          </a:stretch>
+        </p:blipFill>
+        <p:spPr>
+          <a:xfrm>
+            <a:off x="1380565" y="1790087"/>
+            <a:ext cx="9108141" cy="4727254"/>
+          </a:xfrm>
+        </p:spPr>
+      </p:pic>
+    </p:spTree>
+    <p:extLst>
+      <p:ext uri="{BB962C8B-B14F-4D97-AF65-F5344CB8AC3E}">
+        <p14:creationId xmlns:p14="http://schemas.microsoft.com/office/powerpoint/2010/main" val="3123663345"/>
+      </p:ext>
+    </p:extLst>
+  </p:cSld>
+  <p:clrMapOvr>
+    <a:masterClrMapping/>
+  </p:clrMapOvr>
+</p:sld>
+</file>
+
+<file path=ppt/slides/slide22.xml><?xml version="1.0" encoding="utf-8"?>
+<p:sld xmlns:a="http://schemas.openxmlformats.org/drawingml/2006/main" xmlns:r="http://schemas.openxmlformats.org/officeDocument/2006/relationships" xmlns:p="http://schemas.openxmlformats.org/presentationml/2006/main">
+  <p:cSld>
+    <p:spTree>
+      <p:nvGrpSpPr>
+        <p:cNvPr id="1" name=""/>
+        <p:cNvGrpSpPr/>
+        <p:nvPr/>
+      </p:nvGrpSpPr>
+      <p:grpSpPr>
+        <a:xfrm>
+          <a:off x="0" y="0"/>
+          <a:ext cx="0" cy="0"/>
+          <a:chOff x="0" y="0"/>
+          <a:chExt cx="0" cy="0"/>
+        </a:xfrm>
+      </p:grpSpPr>
+      <p:sp>
+        <p:nvSpPr>
+          <p:cNvPr id="2" name="Title 1"/>
+          <p:cNvSpPr>
+            <a:spLocks noGrp="1"/>
+          </p:cNvSpPr>
+          <p:nvPr>
+            <p:ph type="title"/>
+          </p:nvPr>
+        </p:nvSpPr>
+        <p:spPr/>
+        <p:txBody>
+          <a:bodyPr/>
+          <a:lstStyle/>
+          <a:p>
+            <a:r>
+              <a:rPr lang="en-US" dirty="0"/>
+              <a:t>Façade Design Pattern</a:t>
+            </a:r>
+          </a:p>
+        </p:txBody>
+      </p:sp>
+      <p:sp>
+        <p:nvSpPr>
+          <p:cNvPr id="3" name="Content Placeholder 2"/>
+          <p:cNvSpPr>
+            <a:spLocks noGrp="1"/>
+          </p:cNvSpPr>
+          <p:nvPr>
+            <p:ph idx="1"/>
+          </p:nvPr>
+        </p:nvSpPr>
+        <p:spPr/>
+        <p:txBody>
+          <a:bodyPr/>
+          <a:lstStyle/>
+          <a:p>
+            <a:r>
+              <a:rPr lang="en-US" dirty="0"/>
+              <a:t>The Facade Pattern simplifies the interface to a complex system by providing a single class that manages interactions between the system components.</a:t>
+            </a:r>
+          </a:p>
+          <a:p>
+            <a:endParaRPr lang="en-US" dirty="0"/>
+          </a:p>
+        </p:txBody>
+      </p:sp>
+      <p:pic>
+        <p:nvPicPr>
+          <p:cNvPr id="5" name="Picture 4">
+            <a:extLst>
+              <a:ext uri="{FF2B5EF4-FFF2-40B4-BE49-F238E27FC236}">
+                <a16:creationId xmlns:a16="http://schemas.microsoft.com/office/drawing/2014/main" id="{1B243C2F-8339-BB02-1507-858948C26781}"/>
+              </a:ext>
+            </a:extLst>
+          </p:cNvPr>
+          <p:cNvPicPr>
+            <a:picLocks noChangeAspect="1"/>
+          </p:cNvPicPr>
+          <p:nvPr/>
+        </p:nvPicPr>
+        <p:blipFill>
+          <a:blip r:embed="rId2"/>
+          <a:stretch>
+            <a:fillRect/>
+          </a:stretch>
+        </p:blipFill>
+        <p:spPr>
+          <a:xfrm>
+            <a:off x="1333500" y="3155576"/>
+            <a:ext cx="9525000" cy="3249706"/>
+          </a:xfrm>
+          <a:prstGeom prst="rect">
+            <a:avLst/>
+          </a:prstGeom>
+        </p:spPr>
+      </p:pic>
+    </p:spTree>
+    <p:extLst>
+      <p:ext uri="{BB962C8B-B14F-4D97-AF65-F5344CB8AC3E}">
+        <p14:creationId xmlns:p14="http://schemas.microsoft.com/office/powerpoint/2010/main" val="1180489966"/>
+      </p:ext>
+    </p:extLst>
+  </p:cSld>
+  <p:clrMapOvr>
+    <a:masterClrMapping/>
+  </p:clrMapOvr>
+</p:sld>
+</file>
+
+<file path=ppt/slides/slide23.xml><?xml version="1.0" encoding="utf-8"?>
+<p:sld xmlns:a="http://schemas.openxmlformats.org/drawingml/2006/main" xmlns:r="http://schemas.openxmlformats.org/officeDocument/2006/relationships" xmlns:p="http://schemas.openxmlformats.org/presentationml/2006/main">
+  <p:cSld>
+    <p:spTree>
+      <p:nvGrpSpPr>
+        <p:cNvPr id="1" name=""/>
+        <p:cNvGrpSpPr/>
+        <p:nvPr/>
+      </p:nvGrpSpPr>
+      <p:grpSpPr>
+        <a:xfrm>
+          <a:off x="0" y="0"/>
+          <a:ext cx="0" cy="0"/>
+          <a:chOff x="0" y="0"/>
+          <a:chExt cx="0" cy="0"/>
+        </a:xfrm>
+      </p:grpSpPr>
+      <p:sp>
+        <p:nvSpPr>
+          <p:cNvPr id="2" name="Title 1"/>
+          <p:cNvSpPr>
+            <a:spLocks noGrp="1"/>
+          </p:cNvSpPr>
+          <p:nvPr>
+            <p:ph type="title"/>
+          </p:nvPr>
+        </p:nvSpPr>
+        <p:spPr/>
+        <p:txBody>
+          <a:bodyPr/>
+          <a:lstStyle/>
+          <a:p>
+            <a:r>
+              <a:rPr lang="en-US" dirty="0"/>
+              <a:t>Façade Design Pattern</a:t>
+            </a:r>
+          </a:p>
+        </p:txBody>
+      </p:sp>
+      <p:sp>
+        <p:nvSpPr>
+          <p:cNvPr id="3" name="Content Placeholder 2"/>
+          <p:cNvSpPr>
+            <a:spLocks noGrp="1"/>
+          </p:cNvSpPr>
+          <p:nvPr>
+            <p:ph idx="1"/>
+          </p:nvPr>
+        </p:nvSpPr>
+        <p:spPr/>
+        <p:txBody>
+          <a:bodyPr/>
+          <a:lstStyle/>
+          <a:p>
+            <a:endParaRPr lang="en-US" dirty="0"/>
+          </a:p>
+          <a:p>
+            <a:endParaRPr lang="en-US" dirty="0"/>
+          </a:p>
+        </p:txBody>
+      </p:sp>
+      <p:pic>
+        <p:nvPicPr>
+          <p:cNvPr id="6" name="Picture 5">
+            <a:extLst>
+              <a:ext uri="{FF2B5EF4-FFF2-40B4-BE49-F238E27FC236}">
+                <a16:creationId xmlns:a16="http://schemas.microsoft.com/office/drawing/2014/main" id="{13E305CF-B221-35B1-E56E-250567DC7E80}"/>
+              </a:ext>
+            </a:extLst>
+          </p:cNvPr>
+          <p:cNvPicPr>
+            <a:picLocks noChangeAspect="1"/>
+          </p:cNvPicPr>
+          <p:nvPr/>
+        </p:nvPicPr>
+        <p:blipFill>
+          <a:blip r:embed="rId2"/>
+          <a:stretch>
+            <a:fillRect/>
+          </a:stretch>
+        </p:blipFill>
+        <p:spPr>
+          <a:xfrm>
+            <a:off x="1631575" y="1357664"/>
+            <a:ext cx="9780495" cy="5245901"/>
+          </a:xfrm>
+          <a:prstGeom prst="rect">
+            <a:avLst/>
+          </a:prstGeom>
+        </p:spPr>
+      </p:pic>
+    </p:spTree>
+    <p:extLst>
+      <p:ext uri="{BB962C8B-B14F-4D97-AF65-F5344CB8AC3E}">
+        <p14:creationId xmlns:p14="http://schemas.microsoft.com/office/powerpoint/2010/main" val="4250793336"/>
+      </p:ext>
+    </p:extLst>
+  </p:cSld>
+  <p:clrMapOvr>
+    <a:masterClrMapping/>
+  </p:clrMapOvr>
+</p:sld>
+</file>
+
+<file path=ppt/slides/slide24.xml><?xml version="1.0" encoding="utf-8"?>
+<p:sld xmlns:a="http://schemas.openxmlformats.org/drawingml/2006/main" xmlns:r="http://schemas.openxmlformats.org/officeDocument/2006/relationships" xmlns:p="http://schemas.openxmlformats.org/presentationml/2006/main">
+  <p:cSld>
+    <p:spTree>
+      <p:nvGrpSpPr>
+        <p:cNvPr id="1" name=""/>
+        <p:cNvGrpSpPr/>
+        <p:nvPr/>
+      </p:nvGrpSpPr>
+      <p:grpSpPr>
+        <a:xfrm>
+          <a:off x="0" y="0"/>
+          <a:ext cx="0" cy="0"/>
+          <a:chOff x="0" y="0"/>
+          <a:chExt cx="0" cy="0"/>
+        </a:xfrm>
+      </p:grpSpPr>
+      <p:sp>
+        <p:nvSpPr>
+          <p:cNvPr id="2" name="Title 1">
+            <a:extLst>
+              <a:ext uri="{FF2B5EF4-FFF2-40B4-BE49-F238E27FC236}">
+                <a16:creationId xmlns:a16="http://schemas.microsoft.com/office/drawing/2014/main" id="{AC64A20C-15DE-CF77-E8EC-C27237E241E8}"/>
+              </a:ext>
+            </a:extLst>
+          </p:cNvPr>
+          <p:cNvSpPr>
+            <a:spLocks noGrp="1"/>
+          </p:cNvSpPr>
+          <p:nvPr>
+            <p:ph type="title"/>
+          </p:nvPr>
+        </p:nvSpPr>
+        <p:spPr/>
+        <p:txBody>
+          <a:bodyPr/>
+          <a:lstStyle/>
+          <a:p>
+            <a:r>
+              <a:rPr lang="en-IN" dirty="0"/>
+              <a:t>Adapter Design Pattern</a:t>
+            </a:r>
+          </a:p>
+        </p:txBody>
+      </p:sp>
+      <p:pic>
+        <p:nvPicPr>
+          <p:cNvPr id="5" name="Content Placeholder 4">
+            <a:extLst>
+              <a:ext uri="{FF2B5EF4-FFF2-40B4-BE49-F238E27FC236}">
+                <a16:creationId xmlns:a16="http://schemas.microsoft.com/office/drawing/2014/main" id="{AD39DE2C-F34F-C5DA-7B5D-51C50343827B}"/>
+              </a:ext>
+            </a:extLst>
+          </p:cNvPr>
+          <p:cNvPicPr>
+            <a:picLocks noGrp="1" noChangeAspect="1"/>
+          </p:cNvPicPr>
+          <p:nvPr>
+            <p:ph idx="1"/>
+          </p:nvPr>
+        </p:nvPicPr>
+        <p:blipFill>
+          <a:blip r:embed="rId2"/>
+          <a:stretch>
+            <a:fillRect/>
+          </a:stretch>
+        </p:blipFill>
+        <p:spPr>
+          <a:xfrm>
+            <a:off x="2402542" y="3186858"/>
+            <a:ext cx="6653773" cy="3308071"/>
+          </a:xfrm>
+        </p:spPr>
+      </p:pic>
+      <p:sp>
+        <p:nvSpPr>
+          <p:cNvPr id="7" name="TextBox 6">
+            <a:extLst>
+              <a:ext uri="{FF2B5EF4-FFF2-40B4-BE49-F238E27FC236}">
+                <a16:creationId xmlns:a16="http://schemas.microsoft.com/office/drawing/2014/main" id="{6DA5664D-1832-F79A-48D9-8510A4DC7C25}"/>
+              </a:ext>
+            </a:extLst>
+          </p:cNvPr>
+          <p:cNvSpPr txBox="1"/>
+          <p:nvPr/>
+        </p:nvSpPr>
+        <p:spPr>
+          <a:xfrm>
+            <a:off x="824751" y="1415235"/>
+            <a:ext cx="10237695" cy="1754326"/>
+          </a:xfrm>
+          <a:prstGeom prst="rect">
+            <a:avLst/>
+          </a:prstGeom>
+          <a:noFill/>
+        </p:spPr>
+        <p:txBody>
+          <a:bodyPr wrap="square">
+            <a:spAutoFit/>
+          </a:bodyPr>
+          <a:lstStyle/>
+          <a:p>
+            <a:r>
+              <a:rPr lang="en-US" b="0" i="0" dirty="0">
+                <a:solidFill>
+                  <a:srgbClr val="BDC1C6"/>
+                </a:solidFill>
+                <a:effectLst/>
+                <a:latin typeface="Arial" panose="020B0604020202020204" pitchFamily="34" charset="0"/>
+              </a:rPr>
+              <a:t>The </a:t>
+            </a:r>
+            <a:r>
+              <a:rPr lang="en-US" b="1" i="0" dirty="0">
+                <a:solidFill>
+                  <a:srgbClr val="BCC0C3"/>
+                </a:solidFill>
+                <a:effectLst/>
+                <a:latin typeface="Arial" panose="020B0604020202020204" pitchFamily="34" charset="0"/>
+              </a:rPr>
+              <a:t>Adapter design pattern</a:t>
+            </a:r>
+            <a:r>
+              <a:rPr lang="en-US" b="0" i="0" dirty="0">
+                <a:solidFill>
+                  <a:srgbClr val="BDC1C6"/>
+                </a:solidFill>
+                <a:effectLst/>
+                <a:latin typeface="Arial" panose="020B0604020202020204" pitchFamily="34" charset="0"/>
+              </a:rPr>
+              <a:t> is a structural pattern that allows the interface of an existing class to be used as another interface.</a:t>
+            </a:r>
+          </a:p>
+          <a:p>
+            <a:endParaRPr lang="en-US" dirty="0">
+              <a:solidFill>
+                <a:srgbClr val="BDC1C6"/>
+              </a:solidFill>
+              <a:latin typeface="Arial" panose="020B0604020202020204" pitchFamily="34" charset="0"/>
+            </a:endParaRPr>
+          </a:p>
+          <a:p>
+            <a:r>
+              <a:rPr lang="en-US" dirty="0">
+                <a:solidFill>
+                  <a:srgbClr val="BDC1C6"/>
+                </a:solidFill>
+                <a:latin typeface="Arial" panose="020B0604020202020204" pitchFamily="34" charset="0"/>
+              </a:rPr>
+              <a:t>“The Adapter Design pattern allows incompatible interfaces to work together by acting as a bridge between two system. It converts one interface into another that the client expects, enabling interaction between classes that otherwise couldn’t collaborate.”</a:t>
+            </a:r>
+            <a:endParaRPr lang="en-IN" dirty="0"/>
+          </a:p>
+        </p:txBody>
+      </p:sp>
+    </p:spTree>
+    <p:extLst>
+      <p:ext uri="{BB962C8B-B14F-4D97-AF65-F5344CB8AC3E}">
+        <p14:creationId xmlns:p14="http://schemas.microsoft.com/office/powerpoint/2010/main" val="3976769646"/>
+      </p:ext>
+    </p:extLst>
+  </p:cSld>
+  <p:clrMapOvr>
+    <a:masterClrMapping/>
+  </p:clrMapOvr>
+</p:sld>
+</file>
+
+<file path=ppt/slides/slide25.xml><?xml version="1.0" encoding="utf-8"?>
+<p:sld xmlns:a="http://schemas.openxmlformats.org/drawingml/2006/main" xmlns:r="http://schemas.openxmlformats.org/officeDocument/2006/relationships" xmlns:p="http://schemas.openxmlformats.org/presentationml/2006/main">
+  <p:cSld>
+    <p:spTree>
+      <p:nvGrpSpPr>
+        <p:cNvPr id="1" name=""/>
+        <p:cNvGrpSpPr/>
+        <p:nvPr/>
+      </p:nvGrpSpPr>
+      <p:grpSpPr>
+        <a:xfrm>
+          <a:off x="0" y="0"/>
+          <a:ext cx="0" cy="0"/>
+          <a:chOff x="0" y="0"/>
+          <a:chExt cx="0" cy="0"/>
+        </a:xfrm>
+      </p:grpSpPr>
+      <p:sp>
+        <p:nvSpPr>
+          <p:cNvPr id="2" name="Title 1">
+            <a:extLst>
+              <a:ext uri="{FF2B5EF4-FFF2-40B4-BE49-F238E27FC236}">
+                <a16:creationId xmlns:a16="http://schemas.microsoft.com/office/drawing/2014/main" id="{AC64A20C-15DE-CF77-E8EC-C27237E241E8}"/>
+              </a:ext>
+            </a:extLst>
+          </p:cNvPr>
+          <p:cNvSpPr>
+            <a:spLocks noGrp="1"/>
+          </p:cNvSpPr>
+          <p:nvPr>
+            <p:ph type="title"/>
+          </p:nvPr>
+        </p:nvSpPr>
+        <p:spPr/>
+        <p:txBody>
+          <a:bodyPr/>
+          <a:lstStyle/>
+          <a:p>
+            <a:r>
+              <a:rPr lang="en-IN" dirty="0"/>
+              <a:t>Adapter Design Pattern</a:t>
+            </a:r>
+          </a:p>
+        </p:txBody>
+      </p:sp>
+      <p:sp>
+        <p:nvSpPr>
+          <p:cNvPr id="7" name="TextBox 6">
+            <a:extLst>
+              <a:ext uri="{FF2B5EF4-FFF2-40B4-BE49-F238E27FC236}">
+                <a16:creationId xmlns:a16="http://schemas.microsoft.com/office/drawing/2014/main" id="{6DA5664D-1832-F79A-48D9-8510A4DC7C25}"/>
+              </a:ext>
+            </a:extLst>
+          </p:cNvPr>
+          <p:cNvSpPr txBox="1"/>
+          <p:nvPr/>
+        </p:nvSpPr>
+        <p:spPr>
+          <a:xfrm>
+            <a:off x="824751" y="1415235"/>
+            <a:ext cx="10237695" cy="646331"/>
+          </a:xfrm>
+          <a:prstGeom prst="rect">
+            <a:avLst/>
+          </a:prstGeom>
+          <a:noFill/>
+        </p:spPr>
+        <p:txBody>
+          <a:bodyPr wrap="square">
+            <a:spAutoFit/>
+          </a:bodyPr>
+          <a:lstStyle/>
+          <a:p>
+            <a:r>
+              <a:rPr lang="en-US" b="0" i="0" dirty="0">
+                <a:solidFill>
+                  <a:srgbClr val="BDC1C6"/>
+                </a:solidFill>
+                <a:effectLst/>
+                <a:latin typeface="Arial" panose="020B0604020202020204" pitchFamily="34" charset="0"/>
+              </a:rPr>
+              <a:t>The </a:t>
+            </a:r>
+            <a:r>
+              <a:rPr lang="en-US" b="1" i="0" dirty="0">
+                <a:solidFill>
+                  <a:srgbClr val="BCC0C3"/>
+                </a:solidFill>
+                <a:effectLst/>
+                <a:latin typeface="Arial" panose="020B0604020202020204" pitchFamily="34" charset="0"/>
+              </a:rPr>
+              <a:t>Adapter design pattern</a:t>
+            </a:r>
+            <a:r>
+              <a:rPr lang="en-US" b="0" i="0" dirty="0">
+                <a:solidFill>
+                  <a:srgbClr val="BDC1C6"/>
+                </a:solidFill>
+                <a:effectLst/>
+                <a:latin typeface="Arial" panose="020B0604020202020204" pitchFamily="34" charset="0"/>
+              </a:rPr>
+              <a:t> is a structural pattern that allows the interface of an existing class to be used as another interface.</a:t>
+            </a:r>
+            <a:endParaRPr lang="en-IN" dirty="0"/>
+          </a:p>
+        </p:txBody>
+      </p:sp>
+      <p:pic>
+        <p:nvPicPr>
+          <p:cNvPr id="8" name="Content Placeholder 7">
+            <a:extLst>
+              <a:ext uri="{FF2B5EF4-FFF2-40B4-BE49-F238E27FC236}">
+                <a16:creationId xmlns:a16="http://schemas.microsoft.com/office/drawing/2014/main" id="{0890FD21-3685-D772-25A5-FC1FDA9ED228}"/>
+              </a:ext>
+            </a:extLst>
+          </p:cNvPr>
+          <p:cNvPicPr>
+            <a:picLocks noGrp="1" noChangeAspect="1"/>
+          </p:cNvPicPr>
+          <p:nvPr>
+            <p:ph idx="1"/>
+          </p:nvPr>
+        </p:nvPicPr>
+        <p:blipFill>
+          <a:blip r:embed="rId2"/>
+          <a:stretch>
+            <a:fillRect/>
+          </a:stretch>
+        </p:blipFill>
+        <p:spPr>
+          <a:xfrm>
+            <a:off x="1604684" y="2205229"/>
+            <a:ext cx="7619998" cy="3969259"/>
+          </a:xfrm>
+        </p:spPr>
+      </p:pic>
+    </p:spTree>
+    <p:extLst>
+      <p:ext uri="{BB962C8B-B14F-4D97-AF65-F5344CB8AC3E}">
+        <p14:creationId xmlns:p14="http://schemas.microsoft.com/office/powerpoint/2010/main" val="236636376"/>
+      </p:ext>
+    </p:extLst>
+  </p:cSld>
+  <p:clrMapOvr>
+    <a:masterClrMapping/>
+  </p:clrMapOvr>
+</p:sld>
+</file>
+
+<file path=ppt/slides/slide26.xml><?xml version="1.0" encoding="utf-8"?>
+<p:sld xmlns:a="http://schemas.openxmlformats.org/drawingml/2006/main" xmlns:r="http://schemas.openxmlformats.org/officeDocument/2006/relationships" xmlns:p="http://schemas.openxmlformats.org/presentationml/2006/main">
+  <p:cSld>
+    <p:spTree>
+      <p:nvGrpSpPr>
+        <p:cNvPr id="1" name=""/>
+        <p:cNvGrpSpPr/>
+        <p:nvPr/>
+      </p:nvGrpSpPr>
+      <p:grpSpPr>
+        <a:xfrm>
+          <a:off x="0" y="0"/>
+          <a:ext cx="0" cy="0"/>
+          <a:chOff x="0" y="0"/>
+          <a:chExt cx="0" cy="0"/>
+        </a:xfrm>
+      </p:grpSpPr>
+      <p:sp>
+        <p:nvSpPr>
+          <p:cNvPr id="2" name="Title 1">
+            <a:extLst>
+              <a:ext uri="{FF2B5EF4-FFF2-40B4-BE49-F238E27FC236}">
+                <a16:creationId xmlns:a16="http://schemas.microsoft.com/office/drawing/2014/main" id="{D20065B9-4BED-DAE2-C2CD-2071FF4A92E6}"/>
+              </a:ext>
+            </a:extLst>
+          </p:cNvPr>
+          <p:cNvSpPr>
+            <a:spLocks noGrp="1"/>
+          </p:cNvSpPr>
+          <p:nvPr>
+            <p:ph type="title"/>
+          </p:nvPr>
+        </p:nvSpPr>
+        <p:spPr/>
+        <p:txBody>
+          <a:bodyPr/>
+          <a:lstStyle/>
+          <a:p>
+            <a:r>
+              <a:rPr lang="en-IN" dirty="0"/>
+              <a:t>Observer Design Pattern</a:t>
+            </a:r>
+          </a:p>
+        </p:txBody>
+      </p:sp>
+      <p:sp>
+        <p:nvSpPr>
+          <p:cNvPr id="3" name="Content Placeholder 2">
+            <a:extLst>
+              <a:ext uri="{FF2B5EF4-FFF2-40B4-BE49-F238E27FC236}">
+                <a16:creationId xmlns:a16="http://schemas.microsoft.com/office/drawing/2014/main" id="{A01B44D5-ACB5-1F49-FDA8-9E31DD9DECA9}"/>
+              </a:ext>
+            </a:extLst>
+          </p:cNvPr>
+          <p:cNvSpPr>
+            <a:spLocks noGrp="1"/>
+          </p:cNvSpPr>
+          <p:nvPr>
+            <p:ph idx="1"/>
+          </p:nvPr>
+        </p:nvSpPr>
+        <p:spPr/>
+        <p:txBody>
+          <a:bodyPr/>
+          <a:lstStyle/>
+          <a:p>
+            <a:r>
+              <a:rPr lang="en-US" dirty="0"/>
+              <a:t>The Observer Design Pattern is useful when you want to create a subscription model where multiple objects (observers) are notified about changes in another object (subject).</a:t>
+            </a:r>
+          </a:p>
+          <a:p>
+            <a:endParaRPr lang="en-IN" dirty="0"/>
+          </a:p>
+        </p:txBody>
+      </p:sp>
+      <p:pic>
+        <p:nvPicPr>
+          <p:cNvPr id="5" name="Picture 4">
+            <a:extLst>
+              <a:ext uri="{FF2B5EF4-FFF2-40B4-BE49-F238E27FC236}">
+                <a16:creationId xmlns:a16="http://schemas.microsoft.com/office/drawing/2014/main" id="{781FB9E6-B4D1-4070-07A4-782127E04309}"/>
+              </a:ext>
+            </a:extLst>
+          </p:cNvPr>
+          <p:cNvPicPr>
+            <a:picLocks noChangeAspect="1"/>
+          </p:cNvPicPr>
+          <p:nvPr/>
+        </p:nvPicPr>
+        <p:blipFill>
+          <a:blip r:embed="rId2"/>
+          <a:stretch>
+            <a:fillRect/>
+          </a:stretch>
+        </p:blipFill>
+        <p:spPr>
+          <a:xfrm>
+            <a:off x="2205318" y="3281082"/>
+            <a:ext cx="6956611" cy="3348318"/>
+          </a:xfrm>
+          <a:prstGeom prst="rect">
+            <a:avLst/>
+          </a:prstGeom>
+        </p:spPr>
+      </p:pic>
+    </p:spTree>
+    <p:extLst>
+      <p:ext uri="{BB962C8B-B14F-4D97-AF65-F5344CB8AC3E}">
+        <p14:creationId xmlns:p14="http://schemas.microsoft.com/office/powerpoint/2010/main" val="3743000327"/>
+      </p:ext>
+    </p:extLst>
+  </p:cSld>
+  <p:clrMapOvr>
+    <a:masterClrMapping/>
+  </p:clrMapOvr>
+</p:sld>
+</file>
+
+<file path=ppt/slides/slide27.xml><?xml version="1.0" encoding="utf-8"?>
+<p:sld xmlns:a="http://schemas.openxmlformats.org/drawingml/2006/main" xmlns:r="http://schemas.openxmlformats.org/officeDocument/2006/relationships" xmlns:p="http://schemas.openxmlformats.org/presentationml/2006/main">
+  <p:cSld>
+    <p:spTree>
+      <p:nvGrpSpPr>
+        <p:cNvPr id="1" name=""/>
+        <p:cNvGrpSpPr/>
+        <p:nvPr/>
+      </p:nvGrpSpPr>
+      <p:grpSpPr>
+        <a:xfrm>
+          <a:off x="0" y="0"/>
+          <a:ext cx="0" cy="0"/>
+          <a:chOff x="0" y="0"/>
+          <a:chExt cx="0" cy="0"/>
+        </a:xfrm>
+      </p:grpSpPr>
+      <p:sp>
+        <p:nvSpPr>
+          <p:cNvPr id="2" name="Title 1">
+            <a:extLst>
+              <a:ext uri="{FF2B5EF4-FFF2-40B4-BE49-F238E27FC236}">
+                <a16:creationId xmlns:a16="http://schemas.microsoft.com/office/drawing/2014/main" id="{D20065B9-4BED-DAE2-C2CD-2071FF4A92E6}"/>
+              </a:ext>
+            </a:extLst>
+          </p:cNvPr>
+          <p:cNvSpPr>
+            <a:spLocks noGrp="1"/>
+          </p:cNvSpPr>
+          <p:nvPr>
+            <p:ph type="title"/>
+          </p:nvPr>
+        </p:nvSpPr>
+        <p:spPr/>
+        <p:txBody>
+          <a:bodyPr/>
+          <a:lstStyle/>
+          <a:p>
+            <a:r>
+              <a:rPr lang="en-IN" dirty="0"/>
+              <a:t>Observer Design Pattern</a:t>
+            </a:r>
+          </a:p>
+        </p:txBody>
+      </p:sp>
+      <p:pic>
+        <p:nvPicPr>
+          <p:cNvPr id="6" name="Content Placeholder 5">
+            <a:extLst>
+              <a:ext uri="{FF2B5EF4-FFF2-40B4-BE49-F238E27FC236}">
+                <a16:creationId xmlns:a16="http://schemas.microsoft.com/office/drawing/2014/main" id="{4C0D6AF8-605C-3136-F704-6E22823BA819}"/>
+              </a:ext>
+            </a:extLst>
+          </p:cNvPr>
+          <p:cNvPicPr>
+            <a:picLocks noGrp="1" noChangeAspect="1"/>
+          </p:cNvPicPr>
+          <p:nvPr>
+            <p:ph idx="1"/>
+          </p:nvPr>
+        </p:nvPicPr>
+        <p:blipFill>
+          <a:blip r:embed="rId2"/>
+          <a:stretch>
+            <a:fillRect/>
+          </a:stretch>
+        </p:blipFill>
+        <p:spPr>
+          <a:xfrm>
+            <a:off x="518724" y="2110076"/>
+            <a:ext cx="5362123" cy="3654230"/>
+          </a:xfrm>
+        </p:spPr>
+      </p:pic>
+      <p:pic>
+        <p:nvPicPr>
+          <p:cNvPr id="8" name="Picture 7">
+            <a:extLst>
+              <a:ext uri="{FF2B5EF4-FFF2-40B4-BE49-F238E27FC236}">
+                <a16:creationId xmlns:a16="http://schemas.microsoft.com/office/drawing/2014/main" id="{04D10F03-6208-CFD2-EDC5-D3EDE6513EB9}"/>
+              </a:ext>
+            </a:extLst>
+          </p:cNvPr>
+          <p:cNvPicPr>
+            <a:picLocks noChangeAspect="1"/>
+          </p:cNvPicPr>
+          <p:nvPr/>
+        </p:nvPicPr>
+        <p:blipFill>
+          <a:blip r:embed="rId3"/>
+          <a:stretch>
+            <a:fillRect/>
+          </a:stretch>
+        </p:blipFill>
+        <p:spPr>
+          <a:xfrm>
+            <a:off x="6103652" y="2110077"/>
+            <a:ext cx="5569623" cy="3582512"/>
+          </a:xfrm>
+          <a:prstGeom prst="rect">
+            <a:avLst/>
+          </a:prstGeom>
+        </p:spPr>
+      </p:pic>
+    </p:spTree>
+    <p:extLst>
+      <p:ext uri="{BB962C8B-B14F-4D97-AF65-F5344CB8AC3E}">
+        <p14:creationId xmlns:p14="http://schemas.microsoft.com/office/powerpoint/2010/main" val="2692925246"/>
+      </p:ext>
+    </p:extLst>
+  </p:cSld>
+  <p:clrMapOvr>
+    <a:masterClrMapping/>
+  </p:clrMapOvr>
+</p:sld>
+</file>
+
+<file path=ppt/slides/slide28.xml><?xml version="1.0" encoding="utf-8"?>
+<p:sld xmlns:a="http://schemas.openxmlformats.org/drawingml/2006/main" xmlns:r="http://schemas.openxmlformats.org/officeDocument/2006/relationships" xmlns:p="http://schemas.openxmlformats.org/presentationml/2006/main">
+  <p:cSld>
+    <p:spTree>
+      <p:nvGrpSpPr>
+        <p:cNvPr id="1" name=""/>
+        <p:cNvGrpSpPr/>
+        <p:nvPr/>
+      </p:nvGrpSpPr>
+      <p:grpSpPr>
+        <a:xfrm>
+          <a:off x="0" y="0"/>
+          <a:ext cx="0" cy="0"/>
+          <a:chOff x="0" y="0"/>
+          <a:chExt cx="0" cy="0"/>
+        </a:xfrm>
+      </p:grpSpPr>
+      <p:sp>
+        <p:nvSpPr>
+          <p:cNvPr id="2" name="Title 1"/>
+          <p:cNvSpPr>
+            <a:spLocks noGrp="1"/>
+          </p:cNvSpPr>
+          <p:nvPr>
+            <p:ph type="title"/>
+          </p:nvPr>
+        </p:nvSpPr>
+        <p:spPr/>
+        <p:txBody>
+          <a:bodyPr/>
+          <a:lstStyle/>
+          <a:p>
+            <a:r>
+              <a:rPr lang="en-US" dirty="0"/>
+              <a:t>Template Design Pattern</a:t>
+            </a:r>
+          </a:p>
+        </p:txBody>
+      </p:sp>
+      <p:sp>
+        <p:nvSpPr>
+          <p:cNvPr id="3" name="Content Placeholder 2"/>
+          <p:cNvSpPr>
+            <a:spLocks noGrp="1"/>
+          </p:cNvSpPr>
+          <p:nvPr>
+            <p:ph idx="1"/>
+          </p:nvPr>
+        </p:nvSpPr>
+        <p:spPr/>
+        <p:txBody>
+          <a:bodyPr>
+            <a:normAutofit/>
+          </a:bodyPr>
+          <a:lstStyle/>
+          <a:p>
+            <a:r>
+              <a:rPr lang="en-US" dirty="0"/>
+              <a:t>“The Template Method pattern defines the skeleton of an algorithm in a method, deferring some steps to subclasses. It lets subclasses redefine certain steps of an algorithm without changing its structure.”</a:t>
+            </a:r>
+          </a:p>
+          <a:p>
+            <a:r>
+              <a:rPr lang="en-US" dirty="0"/>
+              <a:t>**The Template Method Pattern allows you to define a common process (in this case, processing documents) while allowing subclasses to specify the details of certain steps. </a:t>
+            </a:r>
+          </a:p>
+          <a:p>
+            <a:endParaRPr lang="en-US" dirty="0"/>
+          </a:p>
+        </p:txBody>
+      </p:sp>
+    </p:spTree>
+    <p:extLst>
+      <p:ext uri="{BB962C8B-B14F-4D97-AF65-F5344CB8AC3E}">
+        <p14:creationId xmlns:p14="http://schemas.microsoft.com/office/powerpoint/2010/main" val="1011303848"/>
+      </p:ext>
+    </p:extLst>
+  </p:cSld>
+  <p:clrMapOvr>
+    <a:masterClrMapping/>
+  </p:clrMapOvr>
+</p:sld>
+</file>
+
+<file path=ppt/slides/slide29.xml><?xml version="1.0" encoding="utf-8"?>
+<p:sld xmlns:a="http://schemas.openxmlformats.org/drawingml/2006/main" xmlns:r="http://schemas.openxmlformats.org/officeDocument/2006/relationships" xmlns:p="http://schemas.openxmlformats.org/presentationml/2006/main">
+  <p:cSld>
+    <p:spTree>
+      <p:nvGrpSpPr>
+        <p:cNvPr id="1" name=""/>
+        <p:cNvGrpSpPr/>
+        <p:nvPr/>
+      </p:nvGrpSpPr>
+      <p:grpSpPr>
+        <a:xfrm>
+          <a:off x="0" y="0"/>
+          <a:ext cx="0" cy="0"/>
+          <a:chOff x="0" y="0"/>
+          <a:chExt cx="0" cy="0"/>
+        </a:xfrm>
+      </p:grpSpPr>
+      <p:sp>
+        <p:nvSpPr>
+          <p:cNvPr id="2" name="Title 1">
+            <a:extLst>
+              <a:ext uri="{FF2B5EF4-FFF2-40B4-BE49-F238E27FC236}">
+                <a16:creationId xmlns:a16="http://schemas.microsoft.com/office/drawing/2014/main" id="{820198BF-829C-D8D7-9826-675266D39B88}"/>
+              </a:ext>
+            </a:extLst>
+          </p:cNvPr>
+          <p:cNvSpPr>
+            <a:spLocks noGrp="1"/>
+          </p:cNvSpPr>
+          <p:nvPr>
+            <p:ph type="title"/>
+          </p:nvPr>
+        </p:nvSpPr>
+        <p:spPr/>
+        <p:txBody>
+          <a:bodyPr/>
+          <a:lstStyle/>
+          <a:p>
+            <a:r>
+              <a:rPr lang="en-IN" dirty="0"/>
+              <a:t>Template Design Pattern</a:t>
+            </a:r>
+          </a:p>
+        </p:txBody>
+      </p:sp>
+      <p:pic>
+        <p:nvPicPr>
+          <p:cNvPr id="5" name="Content Placeholder 4">
+            <a:extLst>
+              <a:ext uri="{FF2B5EF4-FFF2-40B4-BE49-F238E27FC236}">
+                <a16:creationId xmlns:a16="http://schemas.microsoft.com/office/drawing/2014/main" id="{2E6E863E-1722-3935-D5E0-00DB4E5E8189}"/>
+              </a:ext>
+            </a:extLst>
+          </p:cNvPr>
+          <p:cNvPicPr>
+            <a:picLocks noGrp="1" noChangeAspect="1"/>
+          </p:cNvPicPr>
+          <p:nvPr>
+            <p:ph idx="1"/>
+          </p:nvPr>
+        </p:nvPicPr>
+        <p:blipFill>
+          <a:blip r:embed="rId2"/>
+          <a:stretch>
+            <a:fillRect/>
+          </a:stretch>
+        </p:blipFill>
+        <p:spPr>
+          <a:xfrm>
+            <a:off x="514129" y="1962991"/>
+            <a:ext cx="6378270" cy="4195762"/>
+          </a:xfrm>
+          <a:prstGeom prst="rect">
+            <a:avLst/>
+          </a:prstGeom>
+        </p:spPr>
+      </p:pic>
+      <p:pic>
+        <p:nvPicPr>
+          <p:cNvPr id="6" name="Picture 5">
+            <a:extLst>
+              <a:ext uri="{FF2B5EF4-FFF2-40B4-BE49-F238E27FC236}">
+                <a16:creationId xmlns:a16="http://schemas.microsoft.com/office/drawing/2014/main" id="{551087BB-95E5-A939-54D7-60F195D49EE6}"/>
+              </a:ext>
+            </a:extLst>
+          </p:cNvPr>
+          <p:cNvPicPr>
+            <a:picLocks noChangeAspect="1"/>
+          </p:cNvPicPr>
+          <p:nvPr/>
+        </p:nvPicPr>
+        <p:blipFill>
+          <a:blip r:embed="rId3"/>
+          <a:stretch>
+            <a:fillRect/>
+          </a:stretch>
+        </p:blipFill>
+        <p:spPr>
+          <a:xfrm>
+            <a:off x="7166442" y="1110503"/>
+            <a:ext cx="4905375" cy="5048250"/>
+          </a:xfrm>
+          <a:prstGeom prst="rect">
+            <a:avLst/>
+          </a:prstGeom>
+        </p:spPr>
+      </p:pic>
+    </p:spTree>
+    <p:extLst>
+      <p:ext uri="{BB962C8B-B14F-4D97-AF65-F5344CB8AC3E}">
+        <p14:creationId xmlns:p14="http://schemas.microsoft.com/office/powerpoint/2010/main" val="814096323"/>
       </p:ext>
     </p:extLst>
   </p:cSld>
@@ -7113,10 +8446,9 @@
           <a:lstStyle/>
           <a:p>
             <a:r>
-              <a:rPr lang="en-US" dirty="0" smtClean="0"/>
+              <a:rPr lang="en-US" dirty="0"/>
               <a:t>Type of Design Patterns</a:t>
             </a:r>
-            <a:endParaRPr lang="en-US" dirty="0"/>
           </a:p>
         </p:txBody>
       </p:sp>
@@ -7141,11 +8473,7 @@
             </a:pPr>
             <a:r>
               <a:rPr lang="en-US" dirty="0"/>
-              <a:t>Creational </a:t>
-            </a:r>
-            <a:r>
-              <a:rPr lang="en-US" dirty="0" smtClean="0"/>
-              <a:t>Patterns</a:t>
+              <a:t>Creational Patterns</a:t>
             </a:r>
           </a:p>
           <a:p>
@@ -7155,11 +8483,7 @@
             </a:pPr>
             <a:r>
               <a:rPr lang="en-US" dirty="0"/>
-              <a:t>Structural </a:t>
-            </a:r>
-            <a:r>
-              <a:rPr lang="en-US" dirty="0" smtClean="0"/>
-              <a:t>Patterns</a:t>
+              <a:t>Structural Patterns</a:t>
             </a:r>
           </a:p>
           <a:p>
@@ -7178,6 +8502,505 @@
     <p:extLst>
       <p:ext uri="{BB962C8B-B14F-4D97-AF65-F5344CB8AC3E}">
         <p14:creationId xmlns:p14="http://schemas.microsoft.com/office/powerpoint/2010/main" val="4058866742"/>
+      </p:ext>
+    </p:extLst>
+  </p:cSld>
+  <p:clrMapOvr>
+    <a:masterClrMapping/>
+  </p:clrMapOvr>
+</p:sld>
+</file>
+
+<file path=ppt/slides/slide30.xml><?xml version="1.0" encoding="utf-8"?>
+<p:sld xmlns:a="http://schemas.openxmlformats.org/drawingml/2006/main" xmlns:r="http://schemas.openxmlformats.org/officeDocument/2006/relationships" xmlns:p="http://schemas.openxmlformats.org/presentationml/2006/main">
+  <p:cSld>
+    <p:spTree>
+      <p:nvGrpSpPr>
+        <p:cNvPr id="1" name=""/>
+        <p:cNvGrpSpPr/>
+        <p:nvPr/>
+      </p:nvGrpSpPr>
+      <p:grpSpPr>
+        <a:xfrm>
+          <a:off x="0" y="0"/>
+          <a:ext cx="0" cy="0"/>
+          <a:chOff x="0" y="0"/>
+          <a:chExt cx="0" cy="0"/>
+        </a:xfrm>
+      </p:grpSpPr>
+      <p:sp>
+        <p:nvSpPr>
+          <p:cNvPr id="2" name="Title 1"/>
+          <p:cNvSpPr>
+            <a:spLocks noGrp="1"/>
+          </p:cNvSpPr>
+          <p:nvPr>
+            <p:ph type="title"/>
+          </p:nvPr>
+        </p:nvSpPr>
+        <p:spPr/>
+        <p:txBody>
+          <a:bodyPr/>
+          <a:lstStyle/>
+          <a:p>
+            <a:r>
+              <a:rPr lang="en-US" dirty="0"/>
+              <a:t>Observer Design Pattern</a:t>
+            </a:r>
+            <a:br>
+              <a:rPr lang="en-US" dirty="0"/>
+            </a:br>
+            <a:endParaRPr lang="en-US" dirty="0"/>
+          </a:p>
+        </p:txBody>
+      </p:sp>
+      <p:sp>
+        <p:nvSpPr>
+          <p:cNvPr id="3" name="Content Placeholder 2"/>
+          <p:cNvSpPr>
+            <a:spLocks noGrp="1"/>
+          </p:cNvSpPr>
+          <p:nvPr>
+            <p:ph idx="1"/>
+          </p:nvPr>
+        </p:nvSpPr>
+        <p:spPr/>
+        <p:txBody>
+          <a:bodyPr>
+            <a:normAutofit fontScale="92500" lnSpcReduction="20000"/>
+          </a:bodyPr>
+          <a:lstStyle/>
+          <a:p>
+            <a:r>
+              <a:rPr lang="en-US" dirty="0"/>
+              <a:t>“The Observer Design Pattern is useful when you want to create a subscription model where multiple objects (observers) are notified about changes in another object (subject).”</a:t>
+            </a:r>
+          </a:p>
+          <a:p>
+            <a:r>
+              <a:rPr lang="en-US" dirty="0"/>
+              <a:t>Example: YouTube, E-com, Spotify, Netflix etc.. Notify the subscribers if any latest content available.</a:t>
+            </a:r>
+          </a:p>
+          <a:p>
+            <a:r>
+              <a:rPr lang="en-US" dirty="0"/>
+              <a:t>Real-Time: </a:t>
+            </a:r>
+            <a:r>
+              <a:rPr lang="en-US" dirty="0" err="1"/>
+              <a:t>WeatherStation</a:t>
+            </a:r>
+            <a:r>
+              <a:rPr lang="en-US" dirty="0"/>
+              <a:t>, here we notify the temperature updates to all the subscribers</a:t>
+            </a:r>
+          </a:p>
+          <a:p>
+            <a:r>
+              <a:rPr lang="en-US" dirty="0"/>
+              <a:t>Summary</a:t>
+            </a:r>
+          </a:p>
+          <a:p>
+            <a:r>
+              <a:rPr lang="en-US" dirty="0"/>
+              <a:t>•	The Observer Design Pattern is useful when you want to create a subscription model where multiple objects (observers) are notified about changes in another object (subject).</a:t>
+            </a:r>
+          </a:p>
+          <a:p>
+            <a:r>
+              <a:rPr lang="en-US" dirty="0"/>
+              <a:t>•	In this implementation, the </a:t>
+            </a:r>
+            <a:r>
+              <a:rPr lang="en-US" dirty="0" err="1"/>
+              <a:t>WeatherStation</a:t>
+            </a:r>
+            <a:r>
+              <a:rPr lang="en-US" dirty="0"/>
+              <a:t> serves as the subject that tracks its state (temperature) and notifies all registered </a:t>
+            </a:r>
+            <a:r>
+              <a:rPr lang="en-US" dirty="0" err="1"/>
+              <a:t>DisplayDevice</a:t>
+            </a:r>
+            <a:r>
+              <a:rPr lang="en-US" dirty="0"/>
+              <a:t> instances whenever the temperature changes.</a:t>
+            </a:r>
+          </a:p>
+          <a:p>
+            <a:endParaRPr lang="en-US" dirty="0"/>
+          </a:p>
+        </p:txBody>
+      </p:sp>
+    </p:spTree>
+    <p:extLst>
+      <p:ext uri="{BB962C8B-B14F-4D97-AF65-F5344CB8AC3E}">
+        <p14:creationId xmlns:p14="http://schemas.microsoft.com/office/powerpoint/2010/main" val="2983634375"/>
+      </p:ext>
+    </p:extLst>
+  </p:cSld>
+  <p:clrMapOvr>
+    <a:masterClrMapping/>
+  </p:clrMapOvr>
+</p:sld>
+</file>
+
+<file path=ppt/slides/slide31.xml><?xml version="1.0" encoding="utf-8"?>
+<p:sld xmlns:a="http://schemas.openxmlformats.org/drawingml/2006/main" xmlns:r="http://schemas.openxmlformats.org/officeDocument/2006/relationships" xmlns:p="http://schemas.openxmlformats.org/presentationml/2006/main">
+  <p:cSld>
+    <p:spTree>
+      <p:nvGrpSpPr>
+        <p:cNvPr id="1" name=""/>
+        <p:cNvGrpSpPr/>
+        <p:nvPr/>
+      </p:nvGrpSpPr>
+      <p:grpSpPr>
+        <a:xfrm>
+          <a:off x="0" y="0"/>
+          <a:ext cx="0" cy="0"/>
+          <a:chOff x="0" y="0"/>
+          <a:chExt cx="0" cy="0"/>
+        </a:xfrm>
+      </p:grpSpPr>
+      <p:sp>
+        <p:nvSpPr>
+          <p:cNvPr id="2" name="Title 1"/>
+          <p:cNvSpPr>
+            <a:spLocks noGrp="1"/>
+          </p:cNvSpPr>
+          <p:nvPr>
+            <p:ph type="title"/>
+          </p:nvPr>
+        </p:nvSpPr>
+        <p:spPr/>
+        <p:txBody>
+          <a:bodyPr/>
+          <a:lstStyle/>
+          <a:p>
+            <a:r>
+              <a:rPr lang="en-US" dirty="0"/>
+              <a:t>Proxy Design Pattern</a:t>
+            </a:r>
+          </a:p>
+        </p:txBody>
+      </p:sp>
+      <p:sp>
+        <p:nvSpPr>
+          <p:cNvPr id="3" name="Content Placeholder 2"/>
+          <p:cNvSpPr>
+            <a:spLocks noGrp="1"/>
+          </p:cNvSpPr>
+          <p:nvPr>
+            <p:ph idx="1"/>
+          </p:nvPr>
+        </p:nvSpPr>
+        <p:spPr/>
+        <p:txBody>
+          <a:bodyPr/>
+          <a:lstStyle/>
+          <a:p>
+            <a:r>
+              <a:rPr lang="en-US" dirty="0"/>
+              <a:t>The Proxy class controls access to the </a:t>
+            </a:r>
+            <a:r>
+              <a:rPr lang="en-US" dirty="0" err="1"/>
+              <a:t>RealResource</a:t>
+            </a:r>
+            <a:r>
+              <a:rPr lang="en-US" dirty="0"/>
+              <a:t> instance. It checks the user's permissions before allowing access to the resource.</a:t>
+            </a:r>
+          </a:p>
+          <a:p>
+            <a:r>
+              <a:rPr lang="en-US" dirty="0"/>
+              <a:t>It act as gatekeeper</a:t>
+            </a:r>
+          </a:p>
+          <a:p>
+            <a:r>
+              <a:rPr lang="en-US" dirty="0"/>
+              <a:t>Ex: </a:t>
+            </a:r>
+            <a:r>
+              <a:rPr lang="en-US" dirty="0" err="1"/>
+              <a:t>Sharepoint</a:t>
+            </a:r>
+            <a:r>
+              <a:rPr lang="en-US" dirty="0"/>
+              <a:t>, repo, tools access links in company</a:t>
+            </a:r>
+          </a:p>
+          <a:p>
+            <a:r>
+              <a:rPr lang="en-US" dirty="0"/>
+              <a:t>Summary :</a:t>
+            </a:r>
+          </a:p>
+          <a:p>
+            <a:r>
+              <a:rPr lang="en-US" dirty="0"/>
+              <a:t> The Proxy Design Pattern is useful when you want to provide a surrogate or placeholder for another object to control access to it.  In this implementation, the Proxy checks the user's permissions before allowing access to the </a:t>
+            </a:r>
+            <a:r>
+              <a:rPr lang="en-US" dirty="0" err="1"/>
+              <a:t>RealResource</a:t>
+            </a:r>
+            <a:r>
+              <a:rPr lang="en-US" dirty="0"/>
+              <a:t>, effectively acting as a gatekeeper.</a:t>
+            </a:r>
+          </a:p>
+        </p:txBody>
+      </p:sp>
+    </p:spTree>
+    <p:extLst>
+      <p:ext uri="{BB962C8B-B14F-4D97-AF65-F5344CB8AC3E}">
+        <p14:creationId xmlns:p14="http://schemas.microsoft.com/office/powerpoint/2010/main" val="4151292056"/>
+      </p:ext>
+    </p:extLst>
+  </p:cSld>
+  <p:clrMapOvr>
+    <a:masterClrMapping/>
+  </p:clrMapOvr>
+</p:sld>
+</file>
+
+<file path=ppt/slides/slide32.xml><?xml version="1.0" encoding="utf-8"?>
+<p:sld xmlns:a="http://schemas.openxmlformats.org/drawingml/2006/main" xmlns:r="http://schemas.openxmlformats.org/officeDocument/2006/relationships" xmlns:p="http://schemas.openxmlformats.org/presentationml/2006/main">
+  <p:cSld>
+    <p:spTree>
+      <p:nvGrpSpPr>
+        <p:cNvPr id="1" name=""/>
+        <p:cNvGrpSpPr/>
+        <p:nvPr/>
+      </p:nvGrpSpPr>
+      <p:grpSpPr>
+        <a:xfrm>
+          <a:off x="0" y="0"/>
+          <a:ext cx="0" cy="0"/>
+          <a:chOff x="0" y="0"/>
+          <a:chExt cx="0" cy="0"/>
+        </a:xfrm>
+      </p:grpSpPr>
+      <p:sp>
+        <p:nvSpPr>
+          <p:cNvPr id="2" name="Title 1"/>
+          <p:cNvSpPr>
+            <a:spLocks noGrp="1"/>
+          </p:cNvSpPr>
+          <p:nvPr>
+            <p:ph type="title"/>
+          </p:nvPr>
+        </p:nvSpPr>
+        <p:spPr/>
+        <p:txBody>
+          <a:bodyPr/>
+          <a:lstStyle/>
+          <a:p>
+            <a:r>
+              <a:rPr lang="en-US" dirty="0"/>
+              <a:t>Mediator Pattern</a:t>
+            </a:r>
+          </a:p>
+        </p:txBody>
+      </p:sp>
+      <p:sp>
+        <p:nvSpPr>
+          <p:cNvPr id="3" name="Content Placeholder 2"/>
+          <p:cNvSpPr>
+            <a:spLocks noGrp="1"/>
+          </p:cNvSpPr>
+          <p:nvPr>
+            <p:ph idx="1"/>
+          </p:nvPr>
+        </p:nvSpPr>
+        <p:spPr/>
+        <p:txBody>
+          <a:bodyPr>
+            <a:normAutofit fontScale="92500" lnSpcReduction="20000"/>
+          </a:bodyPr>
+          <a:lstStyle/>
+          <a:p>
+            <a:r>
+              <a:rPr lang="en-US" dirty="0"/>
+              <a:t>The </a:t>
+            </a:r>
+            <a:r>
+              <a:rPr lang="en-US" b="1" dirty="0"/>
+              <a:t>Mediator Design Pattern</a:t>
+            </a:r>
+            <a:r>
+              <a:rPr lang="en-US" dirty="0"/>
+              <a:t> belongs to the </a:t>
+            </a:r>
+            <a:r>
+              <a:rPr lang="en-US" b="1" dirty="0"/>
+              <a:t>Behavioral Design Patterns</a:t>
+            </a:r>
+            <a:r>
+              <a:rPr lang="en-US" dirty="0"/>
+              <a:t> category.</a:t>
+            </a:r>
+          </a:p>
+          <a:p>
+            <a:r>
+              <a:rPr lang="en-US" dirty="0"/>
+              <a:t>“The Mediator Design Pattern centralizes communication between multiple objects by having them interact through a mediator, rather than directly with each other. This reduces </a:t>
+            </a:r>
+            <a:r>
+              <a:rPr lang="en-US" dirty="0" err="1"/>
+              <a:t>depencies</a:t>
+            </a:r>
+            <a:r>
+              <a:rPr lang="en-US" dirty="0"/>
+              <a:t> and simplifies complex object interactions.”</a:t>
+            </a:r>
+          </a:p>
+          <a:p>
+            <a:r>
+              <a:rPr lang="en-US" dirty="0"/>
+              <a:t>The Mediator pattern defines an object (mediator) that encapsulates how a set of objects interact with each other, reducing direct dependencies between them.</a:t>
+            </a:r>
+          </a:p>
+          <a:p>
+            <a:r>
+              <a:rPr lang="en-US" b="1" dirty="0"/>
+              <a:t>Real-World Example:</a:t>
+            </a:r>
+          </a:p>
+          <a:p>
+            <a:r>
+              <a:rPr lang="en-US" dirty="0"/>
+              <a:t>In a chat application, participants (users) do not communicate directly with each other. Instead, a "</a:t>
+            </a:r>
+            <a:r>
+              <a:rPr lang="en-US" dirty="0" err="1"/>
+              <a:t>ChatRoom</a:t>
+            </a:r>
+            <a:r>
+              <a:rPr lang="en-US" dirty="0"/>
+              <a:t>" (mediator) facilitates communication between users. This way, users are not aware of the other participants' details, and the chat room controls the message flow.</a:t>
+            </a:r>
+          </a:p>
+          <a:p>
+            <a:endParaRPr lang="en-US" dirty="0"/>
+          </a:p>
+        </p:txBody>
+      </p:sp>
+    </p:spTree>
+    <p:extLst>
+      <p:ext uri="{BB962C8B-B14F-4D97-AF65-F5344CB8AC3E}">
+        <p14:creationId xmlns:p14="http://schemas.microsoft.com/office/powerpoint/2010/main" val="959658077"/>
+      </p:ext>
+    </p:extLst>
+  </p:cSld>
+  <p:clrMapOvr>
+    <a:masterClrMapping/>
+  </p:clrMapOvr>
+</p:sld>
+</file>
+
+<file path=ppt/slides/slide33.xml><?xml version="1.0" encoding="utf-8"?>
+<p:sld xmlns:a="http://schemas.openxmlformats.org/drawingml/2006/main" xmlns:r="http://schemas.openxmlformats.org/officeDocument/2006/relationships" xmlns:p="http://schemas.openxmlformats.org/presentationml/2006/main">
+  <p:cSld>
+    <p:spTree>
+      <p:nvGrpSpPr>
+        <p:cNvPr id="1" name=""/>
+        <p:cNvGrpSpPr/>
+        <p:nvPr/>
+      </p:nvGrpSpPr>
+      <p:grpSpPr>
+        <a:xfrm>
+          <a:off x="0" y="0"/>
+          <a:ext cx="0" cy="0"/>
+          <a:chOff x="0" y="0"/>
+          <a:chExt cx="0" cy="0"/>
+        </a:xfrm>
+      </p:grpSpPr>
+      <p:sp>
+        <p:nvSpPr>
+          <p:cNvPr id="2" name="Title 1"/>
+          <p:cNvSpPr>
+            <a:spLocks noGrp="1"/>
+          </p:cNvSpPr>
+          <p:nvPr>
+            <p:ph type="title"/>
+          </p:nvPr>
+        </p:nvSpPr>
+        <p:spPr/>
+        <p:txBody>
+          <a:bodyPr/>
+          <a:lstStyle/>
+          <a:p>
+            <a:r>
+              <a:rPr lang="en-US" dirty="0"/>
+              <a:t>Mediator Pattern</a:t>
+            </a:r>
+          </a:p>
+        </p:txBody>
+      </p:sp>
+      <p:sp>
+        <p:nvSpPr>
+          <p:cNvPr id="3" name="Content Placeholder 2"/>
+          <p:cNvSpPr>
+            <a:spLocks noGrp="1"/>
+          </p:cNvSpPr>
+          <p:nvPr>
+            <p:ph idx="1"/>
+          </p:nvPr>
+        </p:nvSpPr>
+        <p:spPr/>
+        <p:txBody>
+          <a:bodyPr>
+            <a:normAutofit lnSpcReduction="10000"/>
+          </a:bodyPr>
+          <a:lstStyle/>
+          <a:p>
+            <a:r>
+              <a:rPr lang="en-US" dirty="0"/>
+              <a:t>Q. Design and Implement a Mediator pattern to manage communication between a set of objects (e.g., chat room with multiple participants).?</a:t>
+            </a:r>
+          </a:p>
+          <a:p>
+            <a:endParaRPr lang="en-US" dirty="0"/>
+          </a:p>
+          <a:p>
+            <a:r>
+              <a:rPr lang="en-US" dirty="0"/>
+              <a:t>Summary :</a:t>
+            </a:r>
+          </a:p>
+          <a:p>
+            <a:r>
+              <a:rPr lang="en-US" dirty="0"/>
+              <a:t> The Mediator Design Pattern allows for the decoupling of components by using a mediator to facilitate communication between them. </a:t>
+            </a:r>
+          </a:p>
+          <a:p>
+            <a:r>
+              <a:rPr lang="en-US" dirty="0"/>
+              <a:t>In this example, the </a:t>
+            </a:r>
+            <a:r>
+              <a:rPr lang="en-US" dirty="0" err="1"/>
+              <a:t>ChatRoom</a:t>
+            </a:r>
+            <a:r>
+              <a:rPr lang="en-US" dirty="0"/>
+              <a:t> class serves as the mediator that manages the interaction between Participant instances, making the system more organized and reducing dependencies among the components.</a:t>
+            </a:r>
+          </a:p>
+        </p:txBody>
+      </p:sp>
+    </p:spTree>
+    <p:extLst>
+      <p:ext uri="{BB962C8B-B14F-4D97-AF65-F5344CB8AC3E}">
+        <p14:creationId xmlns:p14="http://schemas.microsoft.com/office/powerpoint/2010/main" val="3579317689"/>
       </p:ext>
     </p:extLst>
   </p:cSld>
@@ -7250,24 +9073,12 @@
           <a:p>
             <a:r>
               <a:rPr lang="en-US" dirty="0"/>
-              <a:t>These patterns deal with object creation mechanisms, optimizing the </a:t>
-            </a:r>
-            <a:r>
-              <a:rPr lang="en-US" dirty="0" smtClean="0"/>
-              <a:t>process </a:t>
-            </a:r>
-            <a:r>
-              <a:rPr lang="en-US" dirty="0"/>
-              <a:t>of creating objects</a:t>
-            </a:r>
-            <a:r>
-              <a:rPr lang="en-US" dirty="0" smtClean="0"/>
-              <a:t>.</a:t>
-            </a:r>
-          </a:p>
-          <a:p>
-            <a:r>
-              <a:rPr lang="en-US" dirty="0" smtClean="0"/>
+              <a:t>These patterns deal with object creation mechanisms, optimizing the process of creating objects.</a:t>
+            </a:r>
+          </a:p>
+          <a:p>
+            <a:r>
+              <a:rPr lang="en-US" dirty="0"/>
               <a:t>There are 4 Types:</a:t>
             </a:r>
           </a:p>
@@ -7277,24 +9088,8 @@
               <a:buAutoNum type="arabicPeriod"/>
             </a:pPr>
             <a:r>
-              <a:rPr lang="en-US" dirty="0" smtClean="0"/>
-              <a:t>Singleton</a:t>
-            </a:r>
-            <a:r>
-              <a:rPr lang="en-US" dirty="0"/>
-              <a:t>: Ensures a class has only one instance and provides a </a:t>
-            </a:r>
-            <a:r>
-              <a:rPr lang="en-US" dirty="0" smtClean="0"/>
-              <a:t>global </a:t>
-            </a:r>
-            <a:r>
-              <a:rPr lang="en-US" dirty="0"/>
-              <a:t>point of access. Use it when you need to control access to shared </a:t>
-            </a:r>
-            <a:r>
-              <a:rPr lang="en-US" dirty="0" smtClean="0"/>
-              <a:t>resources.</a:t>
+              <a:rPr lang="en-US" dirty="0"/>
+              <a:t>Singleton: Ensures a class has only one instance and provides a global point of access. Use it when you need to control access to shared resources.</a:t>
             </a:r>
           </a:p>
           <a:p>
@@ -7303,16 +9098,8 @@
               <a:buAutoNum type="arabicPeriod"/>
             </a:pPr>
             <a:r>
-              <a:rPr lang="en-US" dirty="0" smtClean="0"/>
-              <a:t>Factory </a:t>
-            </a:r>
-            <a:r>
-              <a:rPr lang="en-US" dirty="0"/>
-              <a:t>Method: Defines an interface for creating an object but allows subclasses to alter the type of objects that will be created. Use it when a class cannot anticipate the type of objects it needs to </a:t>
-            </a:r>
-            <a:r>
-              <a:rPr lang="en-US" dirty="0" smtClean="0"/>
-              <a:t>create.</a:t>
+              <a:rPr lang="en-US" dirty="0"/>
+              <a:t>Factory Method: Defines an interface for creating an object but allows subclasses to alter the type of objects that will be created. Use it when a class cannot anticipate the type of objects it needs to create.</a:t>
             </a:r>
           </a:p>
           <a:p>
@@ -7321,12 +9108,8 @@
               <a:buAutoNum type="arabicPeriod"/>
             </a:pPr>
             <a:r>
-              <a:rPr lang="en-US" dirty="0" smtClean="0"/>
-              <a:t>Abstract </a:t>
-            </a:r>
-            <a:r>
-              <a:rPr lang="en-US" dirty="0"/>
-              <a:t>Factory: Provides an interface for creating families of related or dependent objects without specifying their concrete classes. Use it when the system needs to be </a:t>
+              <a:rPr lang="en-US" dirty="0"/>
+              <a:t>Abstract Factory: Provides an interface for creating families of related or dependent objects without specifying their concrete classes. Use it when the system needs to be </a:t>
             </a:r>
             <a:r>
               <a:rPr lang="en-US" dirty="0" err="1"/>
@@ -7385,18 +9168,9 @@
           <a:lstStyle/>
           <a:p>
             <a:r>
-              <a:rPr lang="en-US" dirty="0" smtClean="0"/>
-              <a:t>1. </a:t>
-            </a:r>
-            <a:r>
-              <a:rPr lang="en-US" dirty="0"/>
-              <a:t>Creational </a:t>
-            </a:r>
-            <a:r>
-              <a:rPr lang="en-US" dirty="0" smtClean="0"/>
-              <a:t>Patterns(continued)</a:t>
-            </a:r>
-            <a:endParaRPr lang="en-US" dirty="0"/>
+              <a:rPr lang="en-US" dirty="0"/>
+              <a:t>1. Creational Patterns(continued)</a:t>
+            </a:r>
           </a:p>
         </p:txBody>
       </p:sp>
@@ -7417,15 +9191,7 @@
           <a:p>
             <a:r>
               <a:rPr lang="en-US" dirty="0"/>
-              <a:t>5. </a:t>
-            </a:r>
-            <a:r>
-              <a:rPr lang="en-US" dirty="0" smtClean="0"/>
-              <a:t>Builder Pattern: The </a:t>
-            </a:r>
-            <a:r>
-              <a:rPr lang="en-US" dirty="0"/>
-              <a:t>Builder pattern separates the construction of a complex object from its representation. This allows the same construction process to create different representations.</a:t>
+              <a:t>5. Builder Pattern: The Builder pattern separates the construction of a complex object from its representation. This allows the same construction process to create different representations.</a:t>
             </a:r>
           </a:p>
         </p:txBody>
@@ -7501,16 +9267,12 @@
           <a:p>
             <a:r>
               <a:rPr lang="en-US" dirty="0"/>
-              <a:t>These patterns focus on how objects and classes are composed to form larger structures</a:t>
-            </a:r>
-            <a:r>
-              <a:rPr lang="en-US" dirty="0" smtClean="0"/>
-              <a:t>.</a:t>
-            </a:r>
-          </a:p>
-          <a:p>
-            <a:r>
-              <a:rPr lang="en-US" dirty="0" smtClean="0"/>
+              <a:t>These patterns focus on how objects and classes are composed to form larger structures.</a:t>
+            </a:r>
+          </a:p>
+          <a:p>
+            <a:r>
+              <a:rPr lang="en-US" dirty="0"/>
               <a:t>There are 4 types:</a:t>
             </a:r>
           </a:p>
@@ -7520,16 +9282,8 @@
               <a:buAutoNum type="arabicPeriod"/>
             </a:pPr>
             <a:r>
-              <a:rPr lang="en-US" dirty="0" smtClean="0"/>
-              <a:t>Adapter</a:t>
-            </a:r>
-            <a:r>
-              <a:rPr lang="en-US" dirty="0"/>
-              <a:t>: Allows incompatible interfaces to work together. Use it when you want to use an existing class and its interface does not match your </a:t>
-            </a:r>
-            <a:r>
-              <a:rPr lang="en-US" dirty="0" smtClean="0"/>
-              <a:t>requirements.</a:t>
+              <a:rPr lang="en-US" dirty="0"/>
+              <a:t>Adapter: Allows incompatible interfaces to work together. Use it when you want to use an existing class and its interface does not match your requirements.</a:t>
             </a:r>
           </a:p>
           <a:p>
@@ -7538,16 +9292,8 @@
               <a:buAutoNum type="arabicPeriod"/>
             </a:pPr>
             <a:r>
-              <a:rPr lang="en-US" dirty="0" smtClean="0"/>
-              <a:t>Decorator</a:t>
-            </a:r>
-            <a:r>
-              <a:rPr lang="en-US" dirty="0"/>
-              <a:t>: Adds new functionality to an object dynamically. Use it when you need to extend the behavior of objects without modifying their </a:t>
-            </a:r>
-            <a:r>
-              <a:rPr lang="en-US" dirty="0" smtClean="0"/>
-              <a:t>structure.</a:t>
+              <a:rPr lang="en-US" dirty="0"/>
+              <a:t>Decorator: Adds new functionality to an object dynamically. Use it when you need to extend the behavior of objects without modifying their structure.</a:t>
             </a:r>
           </a:p>
           <a:p>
@@ -7556,12 +9302,8 @@
               <a:buAutoNum type="arabicPeriod"/>
             </a:pPr>
             <a:r>
-              <a:rPr lang="en-US" dirty="0" smtClean="0"/>
-              <a:t>Facade</a:t>
-            </a:r>
-            <a:r>
-              <a:rPr lang="en-US" dirty="0"/>
-              <a:t>: Provides a simplified interface to a complex subsystem. Use it when you want to hide the complexities of a system and provide a simpler interface.</a:t>
+              <a:rPr lang="en-US" dirty="0"/>
+              <a:t>Facade: Provides a simplified interface to a complex subsystem. Use it when you want to hide the complexities of a system and provide a simpler interface.</a:t>
             </a:r>
           </a:p>
         </p:txBody>
@@ -7640,15 +9382,7 @@
             </a:pPr>
             <a:r>
               <a:rPr lang="en-US" dirty="0"/>
-              <a:t>5. Proxy </a:t>
-            </a:r>
-            <a:r>
-              <a:rPr lang="en-US" dirty="0" smtClean="0"/>
-              <a:t>Pattern</a:t>
-            </a:r>
-            <a:r>
-              <a:rPr lang="en-US" dirty="0"/>
-              <a:t>: The Proxy pattern provides a surrogate or placeholder for another object to control access to it. This can be useful for various purposes, such as lazy initialization, access control, or logging.</a:t>
+              <a:t>5. Proxy Pattern: The Proxy pattern provides a surrogate or placeholder for another object to control access to it. This can be useful for various purposes, such as lazy initialization, access control, or logging.</a:t>
             </a:r>
           </a:p>
         </p:txBody>
@@ -7724,16 +9458,12 @@
           <a:p>
             <a:r>
               <a:rPr lang="en-US" dirty="0"/>
-              <a:t>These patterns deal with object interaction and responsibility</a:t>
-            </a:r>
-            <a:r>
-              <a:rPr lang="en-US" dirty="0" smtClean="0"/>
-              <a:t>.</a:t>
-            </a:r>
-          </a:p>
-          <a:p>
-            <a:r>
-              <a:rPr lang="en-US" dirty="0" smtClean="0"/>
+              <a:t>These patterns deal with object interaction and responsibility.</a:t>
+            </a:r>
+          </a:p>
+          <a:p>
+            <a:r>
+              <a:rPr lang="en-US" dirty="0"/>
               <a:t>There are 4 types:</a:t>
             </a:r>
           </a:p>
@@ -7744,11 +9474,7 @@
             </a:pPr>
             <a:r>
               <a:rPr lang="en-US" dirty="0"/>
-              <a:t>Observer: Defines a one-to-many dependency between objects so that when one object changes state, all its dependents are notified. Use it when you have a scenario where multiple objects need to be informed about changes in another </a:t>
-            </a:r>
-            <a:r>
-              <a:rPr lang="en-US" dirty="0" smtClean="0"/>
-              <a:t>object.</a:t>
+              <a:t>Observer: Defines a one-to-many dependency between objects so that when one object changes state, all its dependents are notified. Use it when you have a scenario where multiple objects need to be informed about changes in another object.</a:t>
             </a:r>
           </a:p>
           <a:p>
@@ -7757,16 +9483,8 @@
               <a:buAutoNum type="arabicPeriod"/>
             </a:pPr>
             <a:r>
-              <a:rPr lang="en-US" dirty="0" smtClean="0"/>
-              <a:t>Strategy</a:t>
-            </a:r>
-            <a:r>
-              <a:rPr lang="en-US" dirty="0"/>
-              <a:t>: Defines a family of algorithms, encapsulates each one, and makes them interchangeable. Use it when you want to choose an algorithm at </a:t>
-            </a:r>
-            <a:r>
-              <a:rPr lang="en-US" dirty="0" smtClean="0"/>
-              <a:t>runtime.</a:t>
+              <a:rPr lang="en-US" dirty="0"/>
+              <a:t>Strategy: Defines a family of algorithms, encapsulates each one, and makes them interchangeable. Use it when you want to choose an algorithm at runtime.</a:t>
             </a:r>
           </a:p>
           <a:p>
@@ -7775,12 +9493,8 @@
               <a:buAutoNum type="arabicPeriod"/>
             </a:pPr>
             <a:r>
-              <a:rPr lang="en-US" dirty="0" smtClean="0"/>
-              <a:t>Command</a:t>
-            </a:r>
-            <a:r>
-              <a:rPr lang="en-US" dirty="0"/>
-              <a:t>: Encapsulates a request as an object, thereby allowing for parameterization of clients with queues, requests, and operations. Use it when you want to parameterize objects with operations.</a:t>
+              <a:rPr lang="en-US" dirty="0"/>
+              <a:t>Command: Encapsulates a request as an object, thereby allowing for parameterization of clients with queues, requests, and operations. Use it when you want to parameterize objects with operations.</a:t>
             </a:r>
           </a:p>
         </p:txBody>
@@ -7832,13 +9546,8 @@
           <a:p>
             <a:r>
               <a:rPr lang="en-US" dirty="0"/>
-              <a:t>3. Behavioral </a:t>
-            </a:r>
-            <a:r>
-              <a:rPr lang="en-US" dirty="0" smtClean="0"/>
-              <a:t>Patterns(continued)</a:t>
-            </a:r>
-            <a:endParaRPr lang="en-US" dirty="0"/>
+              <a:t>3. Behavioral Patterns(continued)</a:t>
+            </a:r>
           </a:p>
         </p:txBody>
       </p:sp>
@@ -7860,20 +9569,14 @@
           <a:lstStyle/>
           <a:p>
             <a:r>
-              <a:rPr lang="en-US" dirty="0" smtClean="0"/>
-              <a:t>4. Template </a:t>
-            </a:r>
-            <a:r>
-              <a:rPr lang="en-US" dirty="0"/>
-              <a:t>Method </a:t>
-            </a:r>
-            <a:r>
-              <a:rPr lang="en-US" dirty="0" smtClean="0"/>
-              <a:t>Pattern: The </a:t>
-            </a:r>
-            <a:r>
-              <a:rPr lang="en-US" dirty="0"/>
-              <a:t>Template Method pattern defines the skeleton of an algorithm in a method, deferring some steps to subclasses. It lets subclasses redefine certain steps of an algorithm without changing its structure.</a:t>
+              <a:rPr lang="en-US" dirty="0"/>
+              <a:t>4. Template Method Pattern: The Template Method pattern defines the skeleton of an algorithm in a method, deferring some steps to subclasses. It lets subclasses redefine certain steps of an algorithm without changing its structure.</a:t>
+            </a:r>
+          </a:p>
+          <a:p>
+            <a:r>
+              <a:rPr lang="en-US" dirty="0"/>
+              <a:t>5. Mediator</a:t>
             </a:r>
           </a:p>
         </p:txBody>

</xml_diff>